<commit_message>
Refactor PPI results evaluation and update metrics
- Added backup presentations for GraphSAGE.
- Updated evaluation results for unsupervised models in JSON files, reflecting new F1 scores.
- Modified PPI results markdown to include separate columns for supervised and unsupervised selections.
- Enhanced `compile_results.py` to clarify the distinction between supervised and unsupervised selections.
- Adjusted `sweep_ppi_experiments.py` to write unsupervised sweep results to a separate JSON file, ensuring the main evaluation remains stable.
- Updated loss and performance curves images for PPI results.
</commit_message>
<xml_diff>
--- a/presentation/GraphSAGE_presentation.pptx
+++ b/presentation/GraphSAGE_presentation.pptx
@@ -24,17 +24,17 @@
     <p:sldId id="268" r:id="rId18"/>
     <p:sldId id="269" r:id="rId19"/>
     <p:sldId id="270" r:id="rId20"/>
-    <p:sldId id="301" r:id="rId33"/>
-    <p:sldId id="302" r:id="rId34"/>
-    <p:sldId id="271" r:id="rId21"/>
-    <p:sldId id="272" r:id="rId22"/>
-    <p:sldId id="273" r:id="rId23"/>
-    <p:sldId id="274" r:id="rId24"/>
-    <p:sldId id="275" r:id="rId25"/>
-    <p:sldId id="303" r:id="rId35"/>
-    <p:sldId id="276" r:id="rId26"/>
-    <p:sldId id="277" r:id="rId27"/>
-    <p:sldId id="278" r:id="rId28"/>
+    <p:sldId id="301" r:id="rId21"/>
+    <p:sldId id="302" r:id="rId22"/>
+    <p:sldId id="271" r:id="rId23"/>
+    <p:sldId id="272" r:id="rId24"/>
+    <p:sldId id="273" r:id="rId25"/>
+    <p:sldId id="274" r:id="rId26"/>
+    <p:sldId id="275" r:id="rId27"/>
+    <p:sldId id="303" r:id="rId28"/>
+    <p:sldId id="276" r:id="rId29"/>
+    <p:sldId id="277" r:id="rId30"/>
+    <p:sldId id="278" r:id="rId31"/>
   </p:sldIdLst>
   <p:sldSz cx="12192000" cy="6858000"/>
   <p:notesSz cx="6858000" cy="9144000"/>
@@ -4973,7 +4973,7 @@
         <p:spPr>
           <a:xfrm>
             <a:off x="8185800" y="3186876"/>
-            <a:ext cx="3300000" cy="1146468"/>
+            <a:ext cx="3300000" cy="969496"/>
           </a:xfrm>
           <a:prstGeom prst="rect">
             <a:avLst/>
@@ -5072,7 +5072,7 @@
                   <a:srgbClr val="6B7280"/>
                 </a:solidFill>
               </a:rPr>
-              <a:t>“Stack enough detectors → every node gets its own ID badge — a continuous, learnable Weisfeiler-Lehman coloring.”</a:t>
+              <a:t>“Stack enough detectors → every node gets its own ID badge”</a:t>
             </a:r>
           </a:p>
         </p:txBody>
@@ -6145,7 +6145,7 @@
         </p:nvSpPr>
         <p:spPr>
           <a:xfrm>
-            <a:off x="838047" y="3684862"/>
+            <a:off x="838200" y="3429000"/>
             <a:ext cx="1737360" cy="685800"/>
           </a:xfrm>
           <a:prstGeom prst="roundRect">
@@ -6199,7 +6199,7 @@
         </p:nvSpPr>
         <p:spPr>
           <a:xfrm>
-            <a:off x="2575407" y="3684862"/>
+            <a:off x="2575560" y="3429000"/>
             <a:ext cx="457200" cy="685800"/>
           </a:xfrm>
           <a:prstGeom prst="rect">
@@ -6233,7 +6233,7 @@
         </p:nvSpPr>
         <p:spPr>
           <a:xfrm>
-            <a:off x="3032607" y="3684862"/>
+            <a:off x="3032760" y="3429000"/>
             <a:ext cx="1737360" cy="685800"/>
           </a:xfrm>
           <a:prstGeom prst="roundRect">
@@ -6287,7 +6287,7 @@
         </p:nvSpPr>
         <p:spPr>
           <a:xfrm>
-            <a:off x="4769967" y="3684862"/>
+            <a:off x="4770120" y="3429000"/>
             <a:ext cx="457200" cy="685800"/>
           </a:xfrm>
           <a:prstGeom prst="rect">
@@ -6321,7 +6321,7 @@
         </p:nvSpPr>
         <p:spPr>
           <a:xfrm>
-            <a:off x="5227167" y="3684862"/>
+            <a:off x="5227320" y="3429000"/>
             <a:ext cx="1737360" cy="685800"/>
           </a:xfrm>
           <a:prstGeom prst="roundRect">
@@ -6375,7 +6375,7 @@
         </p:nvSpPr>
         <p:spPr>
           <a:xfrm>
-            <a:off x="6964527" y="3684862"/>
+            <a:off x="6964680" y="3429000"/>
             <a:ext cx="457200" cy="685800"/>
           </a:xfrm>
           <a:prstGeom prst="rect">
@@ -6409,7 +6409,7 @@
         </p:nvSpPr>
         <p:spPr>
           <a:xfrm>
-            <a:off x="7421727" y="3684862"/>
+            <a:off x="7421880" y="3429000"/>
             <a:ext cx="1737360" cy="685800"/>
           </a:xfrm>
           <a:prstGeom prst="roundRect">
@@ -6463,7 +6463,7 @@
         </p:nvSpPr>
         <p:spPr>
           <a:xfrm>
-            <a:off x="9159087" y="3684862"/>
+            <a:off x="9159240" y="3429000"/>
             <a:ext cx="457200" cy="685800"/>
           </a:xfrm>
           <a:prstGeom prst="rect">
@@ -6497,7 +6497,7 @@
         </p:nvSpPr>
         <p:spPr>
           <a:xfrm>
-            <a:off x="9616287" y="3684862"/>
+            <a:off x="9616440" y="3429000"/>
             <a:ext cx="1737360" cy="685800"/>
           </a:xfrm>
           <a:prstGeom prst="roundRect">
@@ -6545,14 +6545,42 @@
       </p:sp>
       <p:sp>
         <p:nvSpPr>
-          <p:cNvPr id="14" name="TextBox 13"/>
+          <p:cNvPr id="16" name="TableDivider"/>
+          <p:cNvSpPr/>
+          <p:nvPr/>
+        </p:nvSpPr>
+        <p:spPr>
+          <a:xfrm>
+            <a:off x="685800" y="4334859"/>
+            <a:ext cx="10820095" cy="0"/>
+          </a:xfrm>
+          <a:prstGeom prst="line">
+            <a:avLst/>
+          </a:prstGeom>
+          <a:ln w="9525">
+            <a:solidFill>
+              <a:srgbClr val="E2E7EE"/>
+            </a:solidFill>
+          </a:ln>
+        </p:spPr>
+        <p:txBody>
+          <a:bodyPr/>
+          <a:lstStyle/>
+          <a:p>
+            <a:endParaRPr lang="en-US"/>
+          </a:p>
+        </p:txBody>
+      </p:sp>
+      <p:sp>
+        <p:nvSpPr>
+          <p:cNvPr id="17" name="TableCell"/>
           <p:cNvSpPr txBox="1"/>
           <p:nvPr/>
         </p:nvSpPr>
         <p:spPr>
           <a:xfrm>
-            <a:off x="691610" y="4782142"/>
-            <a:ext cx="10820095" cy="215444"/>
+            <a:off x="838200" y="4454859"/>
+            <a:ext cx="1737360" cy="900000"/>
           </a:xfrm>
           <a:prstGeom prst="rect">
             <a:avLst/>
@@ -6560,35 +6588,297 @@
           <a:noFill/>
         </p:spPr>
         <p:txBody>
-          <a:bodyPr wrap="square" lIns="0" tIns="0" rIns="0" bIns="0">
+          <a:bodyPr wrap="square" lIns="0" tIns="0" rIns="0" bIns="0" anchor="t">
             <a:spAutoFit/>
           </a:bodyPr>
           <a:lstStyle/>
           <a:p>
-            <a:pPr algn="ctr"/>
-            <a:r>
-              <a:rPr sz="1400" b="0" i="0" dirty="0">
-                <a:solidFill>
-                  <a:srgbClr val="262B33"/>
-                </a:solidFill>
-              </a:rPr>
-              <a:t>All four tiers together: </a:t>
-            </a:r>
-            <a:r>
-              <a:rPr sz="1400" b="1" i="0" dirty="0">
-                <a:solidFill>
-                  <a:srgbClr val="1F385C"/>
-                </a:solidFill>
-              </a:rPr>
-              <a:t>75.3 minutes</a:t>
-            </a:r>
-            <a:r>
-              <a:rPr sz="1400" b="0" i="0" dirty="0">
-                <a:solidFill>
-                  <a:srgbClr val="262B33"/>
-                </a:solidFill>
-              </a:rPr>
-              <a:t> total</a:t>
+            <a:pPr algn="l">
+              <a:lnSpc>
+                <a:spcPct val="120000"/>
+              </a:lnSpc>
+              <a:spcAft>
+                <a:spcPts val="200"/>
+              </a:spcAft>
+            </a:pPr>
+            <a:r>
+              <a:rPr sz="1200" b="0" i="0" dirty="0">
+                <a:solidFill>
+                  <a:srgbClr val="262B33"/>
+                </a:solidFill>
+              </a:rPr>
+              <a:t>Random + Raw features</a:t>
+            </a:r>
+          </a:p>
+          <a:p>
+            <a:pPr algn="l">
+              <a:lnSpc>
+                <a:spcPct val="120000"/>
+              </a:lnSpc>
+            </a:pPr>
+            <a:r>
+              <a:rPr sz="1200" b="0" i="0" dirty="0">
+                <a:solidFill>
+                  <a:srgbClr val="262B33"/>
+                </a:solidFill>
+              </a:rPr>
+              <a:t>(SGDClassifier)</a:t>
+            </a:r>
+          </a:p>
+        </p:txBody>
+      </p:sp>
+      <p:sp>
+        <p:nvSpPr>
+          <p:cNvPr id="18" name="TableCell"/>
+          <p:cNvSpPr txBox="1"/>
+          <p:nvPr/>
+        </p:nvSpPr>
+        <p:spPr>
+          <a:xfrm>
+            <a:off x="3032760" y="4454859"/>
+            <a:ext cx="1737360" cy="900000"/>
+          </a:xfrm>
+          <a:prstGeom prst="rect">
+            <a:avLst/>
+          </a:prstGeom>
+          <a:noFill/>
+        </p:spPr>
+        <p:txBody>
+          <a:bodyPr wrap="square" lIns="0" tIns="0" rIns="0" bIns="0" anchor="t">
+            <a:spAutoFit/>
+          </a:bodyPr>
+          <a:lstStyle/>
+          <a:p>
+            <a:pPr algn="l">
+              <a:lnSpc>
+                <a:spcPct val="120000"/>
+              </a:lnSpc>
+              <a:spcAft>
+                <a:spcPts val="200"/>
+              </a:spcAft>
+            </a:pPr>
+            <a:r>
+              <a:rPr sz="1200" b="0" i="0" dirty="0">
+                <a:solidFill>
+                  <a:srgbClr val="262B33"/>
+                </a:solidFill>
+              </a:rPr>
+              <a:t>2 LR × small only</a:t>
+            </a:r>
+          </a:p>
+          <a:p>
+            <a:pPr algn="l">
+              <a:lnSpc>
+                <a:spcPct val="120000"/>
+              </a:lnSpc>
+            </a:pPr>
+            <a:r>
+              <a:rPr sz="1200" b="0" i="0" dirty="0">
+                <a:solidFill>
+                  <a:srgbClr val="262B33"/>
+                </a:solidFill>
+              </a:rPr>
+              <a:t>sup 10 ep · unsup 3k steps</a:t>
+            </a:r>
+          </a:p>
+        </p:txBody>
+      </p:sp>
+      <p:sp>
+        <p:nvSpPr>
+          <p:cNvPr id="19" name="TableCell"/>
+          <p:cNvSpPr txBox="1"/>
+          <p:nvPr/>
+        </p:nvSpPr>
+        <p:spPr>
+          <a:xfrm>
+            <a:off x="5227320" y="4454859"/>
+            <a:ext cx="1737360" cy="900000"/>
+          </a:xfrm>
+          <a:prstGeom prst="rect">
+            <a:avLst/>
+          </a:prstGeom>
+          <a:noFill/>
+        </p:spPr>
+        <p:txBody>
+          <a:bodyPr wrap="square" lIns="0" tIns="0" rIns="0" bIns="0" anchor="t">
+            <a:spAutoFit/>
+          </a:bodyPr>
+          <a:lstStyle/>
+          <a:p>
+            <a:pPr algn="l">
+              <a:lnSpc>
+                <a:spcPct val="120000"/>
+              </a:lnSpc>
+              <a:spcAft>
+                <a:spcPts val="200"/>
+              </a:spcAft>
+            </a:pPr>
+            <a:r>
+              <a:rPr sz="1200" b="0" i="0" dirty="0">
+                <a:solidFill>
+                  <a:srgbClr val="262B33"/>
+                </a:solidFill>
+              </a:rPr>
+              <a:t>seeds 123, 124</a:t>
+            </a:r>
+          </a:p>
+          <a:p>
+            <a:pPr algn="l">
+              <a:lnSpc>
+                <a:spcPct val="120000"/>
+              </a:lnSpc>
+            </a:pPr>
+            <a:r>
+              <a:rPr sz="1200" b="0" i="0" dirty="0">
+                <a:solidFill>
+                  <a:srgbClr val="262B33"/>
+                </a:solidFill>
+              </a:rPr>
+              <a:t>sup 5 ep · unsup 3k steps</a:t>
+            </a:r>
+          </a:p>
+        </p:txBody>
+      </p:sp>
+      <p:sp>
+        <p:nvSpPr>
+          <p:cNvPr id="20" name="TableCell"/>
+          <p:cNvSpPr txBox="1"/>
+          <p:nvPr/>
+        </p:nvSpPr>
+        <p:spPr>
+          <a:xfrm>
+            <a:off x="7421880" y="4454859"/>
+            <a:ext cx="1737360" cy="675698"/>
+          </a:xfrm>
+          <a:prstGeom prst="rect">
+            <a:avLst/>
+          </a:prstGeom>
+          <a:noFill/>
+        </p:spPr>
+        <p:txBody>
+          <a:bodyPr wrap="square" lIns="0" tIns="0" rIns="0" bIns="0" anchor="t">
+            <a:spAutoFit/>
+          </a:bodyPr>
+          <a:lstStyle/>
+          <a:p>
+            <a:pPr algn="l">
+              <a:lnSpc>
+                <a:spcPct val="120000"/>
+              </a:lnSpc>
+              <a:spcAft>
+                <a:spcPts val="200"/>
+              </a:spcAft>
+            </a:pPr>
+            <a:r>
+              <a:rPr sz="1200" b="0" i="0" dirty="0">
+                <a:solidFill>
+                  <a:srgbClr val="262B33"/>
+                </a:solidFill>
+              </a:rPr>
+              <a:t>K∈{1,2,3} · S∈{5,10,25,50,75}</a:t>
+            </a:r>
+          </a:p>
+          <a:p>
+            <a:pPr algn="l">
+              <a:lnSpc>
+                <a:spcPct val="120000"/>
+              </a:lnSpc>
+            </a:pPr>
+            <a:r>
+              <a:rPr lang="it-IT" sz="1200" dirty="0">
+                <a:solidFill>
+                  <a:srgbClr val="262B33"/>
+                </a:solidFill>
+              </a:rPr>
+              <a:t>G</a:t>
+            </a:r>
+            <a:r>
+              <a:rPr sz="1200" b="0" i="0" dirty="0" err="1">
+                <a:solidFill>
+                  <a:srgbClr val="262B33"/>
+                </a:solidFill>
+              </a:rPr>
+              <a:t>raph</a:t>
+            </a:r>
+            <a:r>
+              <a:rPr lang="it-IT" sz="1200" b="0" i="0" dirty="0">
+                <a:solidFill>
+                  <a:srgbClr val="262B33"/>
+                </a:solidFill>
+              </a:rPr>
+              <a:t>SAGE</a:t>
+            </a:r>
+            <a:r>
+              <a:rPr lang="it-IT" sz="1200" dirty="0">
+                <a:solidFill>
+                  <a:srgbClr val="262B33"/>
+                </a:solidFill>
+              </a:rPr>
+              <a:t>-</a:t>
+            </a:r>
+            <a:r>
+              <a:rPr sz="1200" b="0" i="0" dirty="0">
+                <a:solidFill>
+                  <a:srgbClr val="262B33"/>
+                </a:solidFill>
+              </a:rPr>
+              <a:t>mean, 5 ep</a:t>
+            </a:r>
+          </a:p>
+        </p:txBody>
+      </p:sp>
+      <p:sp>
+        <p:nvSpPr>
+          <p:cNvPr id="21" name="TableCell"/>
+          <p:cNvSpPr txBox="1"/>
+          <p:nvPr/>
+        </p:nvSpPr>
+        <p:spPr>
+          <a:xfrm>
+            <a:off x="9616440" y="4454859"/>
+            <a:ext cx="1737360" cy="900000"/>
+          </a:xfrm>
+          <a:prstGeom prst="rect">
+            <a:avLst/>
+          </a:prstGeom>
+          <a:noFill/>
+        </p:spPr>
+        <p:txBody>
+          <a:bodyPr wrap="square" lIns="0" tIns="0" rIns="0" bIns="0" anchor="t">
+            <a:spAutoFit/>
+          </a:bodyPr>
+          <a:lstStyle/>
+          <a:p>
+            <a:pPr algn="l">
+              <a:lnSpc>
+                <a:spcPct val="120000"/>
+              </a:lnSpc>
+              <a:spcAft>
+                <a:spcPts val="200"/>
+              </a:spcAft>
+            </a:pPr>
+            <a:r>
+              <a:rPr sz="1200" b="0" i="0" dirty="0">
+                <a:solidFill>
+                  <a:srgbClr val="262B33"/>
+                </a:solidFill>
+              </a:rPr>
+              <a:t>noise∈{0, .5, 1}</a:t>
+            </a:r>
+          </a:p>
+          <a:p>
+            <a:pPr algn="l">
+              <a:lnSpc>
+                <a:spcPct val="120000"/>
+              </a:lnSpc>
+            </a:pPr>
+            <a:r>
+              <a:rPr sz="1200" b="0" i="0" dirty="0">
+                <a:solidFill>
+                  <a:srgbClr val="262B33"/>
+                </a:solidFill>
+              </a:rPr>
+              <a:t>GCN + pool, 5 ep</a:t>
             </a:r>
           </a:p>
         </p:txBody>
@@ -7539,7 +7829,7 @@
                   <a:srgbClr val="262B33"/>
                 </a:solidFill>
               </a:rPr>
-              <a:t> (weakest): unsupervised loss over training</a:t>
+              <a:t>: unsupervised loss over training</a:t>
             </a:r>
           </a:p>
         </p:txBody>
@@ -8077,7 +8367,7 @@
                   <a:srgbClr val="262B33"/>
                 </a:solidFill>
               </a:rPr>
-              <a:t> (weakest): unsupervised performance (MRR) over training</a:t>
+              <a:t>: unsupervised performance (MRR) over training</a:t>
             </a:r>
           </a:p>
         </p:txBody>
@@ -8985,99 +9275,19 @@
           <a:p>
             <a:pPr algn="l"/>
             <a:r>
-              <a:rPr sz="1300" b="1" i="0">
+              <a:rPr sz="1300" b="1" i="0" dirty="0">
                 <a:solidFill>
                   <a:srgbClr val="1BAF7A"/>
                 </a:solidFill>
               </a:rPr>
-              <a:t>11 · EMBEDDING EVOLUTION</a:t>
-            </a:r>
-          </a:p>
-        </p:txBody>
-      </p:sp>
-      <p:sp>
-        <p:nvSpPr>
-          <p:cNvPr id="3" name="TextBox 2"/>
-          <p:cNvSpPr txBox="1"/>
-          <p:nvPr/>
-        </p:nvSpPr>
-        <p:spPr>
-          <a:xfrm>
-            <a:off x="685800" y="786384"/>
-            <a:ext cx="10820095" cy="868680"/>
-          </a:xfrm>
-          <a:prstGeom prst="rect">
-            <a:avLst/>
-          </a:prstGeom>
-          <a:noFill/>
-        </p:spPr>
-        <p:txBody>
-          <a:bodyPr wrap="square" lIns="0" tIns="0" rIns="0" bIns="0">
-            <a:spAutoFit/>
-          </a:bodyPr>
-          <a:lstStyle/>
-          <a:p>
-            <a:pPr algn="l">
-              <a:lnSpc>
-                <a:spcPct val="105000"/>
-              </a:lnSpc>
-            </a:pPr>
-            <a:r>
-              <a:rPr sz="3000" b="1" i="0">
-                <a:solidFill>
-                  <a:srgbClr val="1F385C"/>
-                </a:solidFill>
-              </a:rPr>
-              <a:t>Step 0</a:t>
-            </a:r>
-          </a:p>
-        </p:txBody>
-      </p:sp>
-      <p:sp>
-        <p:nvSpPr>
-          <p:cNvPr id="4" name="TextBox 3"/>
-          <p:cNvSpPr txBox="1"/>
-          <p:nvPr/>
-        </p:nvSpPr>
-        <p:spPr>
-          <a:xfrm>
-            <a:off x="685800" y="1783080"/>
-            <a:ext cx="10820095" cy="246221"/>
-          </a:xfrm>
-          <a:prstGeom prst="rect">
-            <a:avLst/>
-          </a:prstGeom>
-          <a:noFill/>
-        </p:spPr>
-        <p:txBody>
-          <a:bodyPr wrap="square" lIns="0" tIns="0" rIns="0" bIns="0">
-            <a:spAutoFit/>
-          </a:bodyPr>
-          <a:lstStyle/>
-          <a:p>
-            <a:pPr algn="ctr"/>
-            <a:r>
-              <a:rPr sz="1600" b="0" i="0" dirty="0">
-                <a:solidFill>
-                  <a:srgbClr val="262B33"/>
-                </a:solidFill>
-              </a:rPr>
-              <a:t>Right after initialization: </a:t>
-            </a:r>
-            <a:r>
-              <a:rPr sz="1600" b="1" i="0" dirty="0">
-                <a:solidFill>
-                  <a:srgbClr val="1F385C"/>
-                </a:solidFill>
-              </a:rPr>
-              <a:t>structurally different nodes not yet separated</a:t>
+              <a:t>10 · TRAINING DYNAMICS</a:t>
             </a:r>
           </a:p>
         </p:txBody>
       </p:sp>
       <p:pic>
         <p:nvPicPr>
-          <p:cNvPr id="5" name="Picture 4" descr="slide16_img13.png"/>
+          <p:cNvPr id="3" name="Picture 3" descr="panel3.png"/>
           <p:cNvPicPr>
             <a:picLocks noChangeAspect="1"/>
           </p:cNvPicPr>
@@ -9091,8 +9301,8 @@
         </p:blipFill>
         <p:spPr>
           <a:xfrm>
-            <a:off x="864222" y="2377440"/>
-            <a:ext cx="4867244" cy="3886200"/>
+            <a:off x="2642067" y="900000"/>
+            <a:ext cx="3253780" cy="2585000"/>
           </a:xfrm>
           <a:prstGeom prst="rect">
             <a:avLst/>
@@ -9101,7 +9311,7 @@
       </p:pic>
       <p:pic>
         <p:nvPicPr>
-          <p:cNvPr id="6" name="Picture 5" descr="slide16_img14.png"/>
+          <p:cNvPr id="4" name="Picture 4" descr="panel4.png"/>
           <p:cNvPicPr>
             <a:picLocks noChangeAspect="1"/>
           </p:cNvPicPr>
@@ -9115,8 +9325,56 @@
         </p:blipFill>
         <p:spPr>
           <a:xfrm>
-            <a:off x="6232664" y="2377440"/>
-            <a:ext cx="5095100" cy="3886200"/>
+            <a:off x="6295847" y="900000"/>
+            <a:ext cx="3253780" cy="2585000"/>
+          </a:xfrm>
+          <a:prstGeom prst="rect">
+            <a:avLst/>
+          </a:prstGeom>
+        </p:spPr>
+      </p:pic>
+      <p:pic>
+        <p:nvPicPr>
+          <p:cNvPr id="5" name="Picture 5" descr="panel5.png"/>
+          <p:cNvPicPr>
+            <a:picLocks noChangeAspect="1"/>
+          </p:cNvPicPr>
+          <p:nvPr/>
+        </p:nvPicPr>
+        <p:blipFill>
+          <a:blip r:embed="rId4"/>
+          <a:stretch>
+            <a:fillRect/>
+          </a:stretch>
+        </p:blipFill>
+        <p:spPr>
+          <a:xfrm>
+            <a:off x="2642067" y="3765000"/>
+            <a:ext cx="3253780" cy="2585000"/>
+          </a:xfrm>
+          <a:prstGeom prst="rect">
+            <a:avLst/>
+          </a:prstGeom>
+        </p:spPr>
+      </p:pic>
+      <p:pic>
+        <p:nvPicPr>
+          <p:cNvPr id="6" name="Picture 6" descr="panel6.png"/>
+          <p:cNvPicPr>
+            <a:picLocks noChangeAspect="1"/>
+          </p:cNvPicPr>
+          <p:nvPr/>
+        </p:nvPicPr>
+        <p:blipFill>
+          <a:blip r:embed="rId5"/>
+          <a:stretch>
+            <a:fillRect/>
+          </a:stretch>
+        </p:blipFill>
+        <p:spPr>
+          <a:xfrm>
+            <a:off x="6295847" y="3765000"/>
+            <a:ext cx="3253780" cy="2585000"/>
           </a:xfrm>
           <a:prstGeom prst="rect">
             <a:avLst/>
@@ -9152,7 +9410,7 @@
                   <a:srgbClr val="9AA5B1"/>
                 </a:solidFill>
               </a:rPr>
-              <a:t>22</a:t>
+              <a:t>20</a:t>
             </a:r>
           </a:p>
         </p:txBody>
@@ -9206,99 +9464,19 @@
           <a:p>
             <a:pPr algn="l"/>
             <a:r>
-              <a:rPr sz="1300" b="1" i="0">
+              <a:rPr sz="1300" b="1" i="0" dirty="0">
                 <a:solidFill>
                   <a:srgbClr val="1BAF7A"/>
                 </a:solidFill>
               </a:rPr>
-              <a:t>11 · EMBEDDING EVOLUTION</a:t>
-            </a:r>
-          </a:p>
-        </p:txBody>
-      </p:sp>
-      <p:sp>
-        <p:nvSpPr>
-          <p:cNvPr id="3" name="TextBox 2"/>
-          <p:cNvSpPr txBox="1"/>
-          <p:nvPr/>
-        </p:nvSpPr>
-        <p:spPr>
-          <a:xfrm>
-            <a:off x="685800" y="786384"/>
-            <a:ext cx="10820095" cy="868680"/>
-          </a:xfrm>
-          <a:prstGeom prst="rect">
-            <a:avLst/>
-          </a:prstGeom>
-          <a:noFill/>
-        </p:spPr>
-        <p:txBody>
-          <a:bodyPr wrap="square" lIns="0" tIns="0" rIns="0" bIns="0">
-            <a:spAutoFit/>
-          </a:bodyPr>
-          <a:lstStyle/>
-          <a:p>
-            <a:pPr algn="l">
-              <a:lnSpc>
-                <a:spcPct val="105000"/>
-              </a:lnSpc>
-            </a:pPr>
-            <a:r>
-              <a:rPr sz="3000" b="1" i="0">
-                <a:solidFill>
-                  <a:srgbClr val="1F385C"/>
-                </a:solidFill>
-              </a:rPr>
-              <a:t>Step 200</a:t>
-            </a:r>
-          </a:p>
-        </p:txBody>
-      </p:sp>
-      <p:sp>
-        <p:nvSpPr>
-          <p:cNvPr id="4" name="TextBox 3"/>
-          <p:cNvSpPr txBox="1"/>
-          <p:nvPr/>
-        </p:nvSpPr>
-        <p:spPr>
-          <a:xfrm>
-            <a:off x="685800" y="1783080"/>
-            <a:ext cx="10820095" cy="246221"/>
-          </a:xfrm>
-          <a:prstGeom prst="rect">
-            <a:avLst/>
-          </a:prstGeom>
-          <a:noFill/>
-        </p:spPr>
-        <p:txBody>
-          <a:bodyPr wrap="square" lIns="0" tIns="0" rIns="0" bIns="0">
-            <a:spAutoFit/>
-          </a:bodyPr>
-          <a:lstStyle/>
-          <a:p>
-            <a:pPr algn="ctr"/>
-            <a:r>
-              <a:rPr sz="1600" b="0" i="0" dirty="0">
-                <a:solidFill>
-                  <a:srgbClr val="262B33"/>
-                </a:solidFill>
-              </a:rPr>
-              <a:t>Cluster structure already largely in place: </a:t>
-            </a:r>
-            <a:r>
-              <a:rPr sz="1600" b="1" i="0" dirty="0">
-                <a:solidFill>
-                  <a:srgbClr val="1F385C"/>
-                </a:solidFill>
-              </a:rPr>
-              <a:t>~85× fewer steps than a full epoch</a:t>
+              <a:t>10 · TRAINING DYNAMICS</a:t>
             </a:r>
           </a:p>
         </p:txBody>
       </p:sp>
       <p:pic>
         <p:nvPicPr>
-          <p:cNvPr id="5" name="Picture 4" descr="slide17_img15.png"/>
+          <p:cNvPr id="3" name="Picture 3" descr="panel3.png"/>
           <p:cNvPicPr>
             <a:picLocks noChangeAspect="1"/>
           </p:cNvPicPr>
@@ -9312,8 +9490,8 @@
         </p:blipFill>
         <p:spPr>
           <a:xfrm>
-            <a:off x="864222" y="2377440"/>
-            <a:ext cx="4867244" cy="3886200"/>
+            <a:off x="2642067" y="900000"/>
+            <a:ext cx="3253780" cy="2585000"/>
           </a:xfrm>
           <a:prstGeom prst="rect">
             <a:avLst/>
@@ -9322,7 +9500,7 @@
       </p:pic>
       <p:pic>
         <p:nvPicPr>
-          <p:cNvPr id="6" name="Picture 5" descr="slide17_img16.png"/>
+          <p:cNvPr id="4" name="Picture 4" descr="panel4.png"/>
           <p:cNvPicPr>
             <a:picLocks noChangeAspect="1"/>
           </p:cNvPicPr>
@@ -9336,8 +9514,56 @@
         </p:blipFill>
         <p:spPr>
           <a:xfrm>
-            <a:off x="6232664" y="2377440"/>
-            <a:ext cx="5095100" cy="3886200"/>
+            <a:off x="6295847" y="900000"/>
+            <a:ext cx="3253780" cy="2585000"/>
+          </a:xfrm>
+          <a:prstGeom prst="rect">
+            <a:avLst/>
+          </a:prstGeom>
+        </p:spPr>
+      </p:pic>
+      <p:pic>
+        <p:nvPicPr>
+          <p:cNvPr id="5" name="Picture 5" descr="panel5.png"/>
+          <p:cNvPicPr>
+            <a:picLocks noChangeAspect="1"/>
+          </p:cNvPicPr>
+          <p:nvPr/>
+        </p:nvPicPr>
+        <p:blipFill>
+          <a:blip r:embed="rId4"/>
+          <a:stretch>
+            <a:fillRect/>
+          </a:stretch>
+        </p:blipFill>
+        <p:spPr>
+          <a:xfrm>
+            <a:off x="2642067" y="3765000"/>
+            <a:ext cx="3253780" cy="2585000"/>
+          </a:xfrm>
+          <a:prstGeom prst="rect">
+            <a:avLst/>
+          </a:prstGeom>
+        </p:spPr>
+      </p:pic>
+      <p:pic>
+        <p:nvPicPr>
+          <p:cNvPr id="6" name="Picture 6" descr="panel6.png"/>
+          <p:cNvPicPr>
+            <a:picLocks noChangeAspect="1"/>
+          </p:cNvPicPr>
+          <p:nvPr/>
+        </p:nvPicPr>
+        <p:blipFill>
+          <a:blip r:embed="rId5"/>
+          <a:stretch>
+            <a:fillRect/>
+          </a:stretch>
+        </p:blipFill>
+        <p:spPr>
+          <a:xfrm>
+            <a:off x="6295847" y="3765000"/>
+            <a:ext cx="3253780" cy="2585000"/>
           </a:xfrm>
           <a:prstGeom prst="rect">
             <a:avLst/>
@@ -9373,7 +9599,7 @@
                   <a:srgbClr val="9AA5B1"/>
                 </a:solidFill>
               </a:rPr>
-              <a:t>23</a:t>
+              <a:t>21</a:t>
             </a:r>
           </a:p>
         </p:txBody>
@@ -9465,28 +9691,12 @@
               </a:lnSpc>
             </a:pPr>
             <a:r>
-              <a:rPr sz="3000" b="1" i="0" dirty="0">
-                <a:solidFill>
-                  <a:srgbClr val="1F385C"/>
-                </a:solidFill>
-              </a:rPr>
-              <a:t>Step 17</a:t>
-            </a:r>
-            <a:r>
-              <a:rPr lang="it-IT" sz="3000" b="1" i="0" dirty="0">
-                <a:solidFill>
-                  <a:srgbClr val="1F385C"/>
-                </a:solidFill>
-              </a:rPr>
-              <a:t>,</a:t>
-            </a:r>
-            <a:r>
-              <a:rPr sz="3000" b="1" i="0" dirty="0">
-                <a:solidFill>
-                  <a:srgbClr val="1F385C"/>
-                </a:solidFill>
-              </a:rPr>
-              <a:t>050</a:t>
+              <a:rPr sz="3000" b="1" i="0">
+                <a:solidFill>
+                  <a:srgbClr val="1F385C"/>
+                </a:solidFill>
+              </a:rPr>
+              <a:t>Step 0</a:t>
             </a:r>
           </a:p>
         </p:txBody>
@@ -9520,7 +9730,7 @@
                   <a:srgbClr val="262B33"/>
                 </a:solidFill>
               </a:rPr>
-              <a:t>Final stage (~1 full epoch): </a:t>
+              <a:t>Right after initialization: </a:t>
             </a:r>
             <a:r>
               <a:rPr sz="1600" b="1" i="0" dirty="0">
@@ -9528,14 +9738,14 @@
                   <a:srgbClr val="1F385C"/>
                 </a:solidFill>
               </a:rPr>
-              <a:t>training mostly refines distances/density from here</a:t>
+              <a:t>structurally different nodes not yet separated</a:t>
             </a:r>
           </a:p>
         </p:txBody>
       </p:sp>
       <p:pic>
         <p:nvPicPr>
-          <p:cNvPr id="5" name="Picture 4" descr="slide18_img17.png"/>
+          <p:cNvPr id="5" name="Picture 4" descr="slide16_img13.png"/>
           <p:cNvPicPr>
             <a:picLocks noChangeAspect="1"/>
           </p:cNvPicPr>
@@ -9559,7 +9769,7 @@
       </p:pic>
       <p:pic>
         <p:nvPicPr>
-          <p:cNvPr id="6" name="Picture 5" descr="slide18_img18.png"/>
+          <p:cNvPr id="6" name="Picture 5" descr="slide16_img14.png"/>
           <p:cNvPicPr>
             <a:picLocks noChangeAspect="1"/>
           </p:cNvPicPr>
@@ -9610,7 +9820,7 @@
                   <a:srgbClr val="9AA5B1"/>
                 </a:solidFill>
               </a:rPr>
-              <a:t>24</a:t>
+              <a:t>22</a:t>
             </a:r>
           </a:p>
         </p:txBody>
@@ -9683,7 +9893,7 @@
         <p:spPr>
           <a:xfrm>
             <a:off x="685800" y="786384"/>
-            <a:ext cx="10820095" cy="465127"/>
+            <a:ext cx="10820095" cy="868680"/>
           </a:xfrm>
           <a:prstGeom prst="rect">
             <a:avLst/>
@@ -9702,12 +9912,12 @@
               </a:lnSpc>
             </a:pPr>
             <a:r>
-              <a:rPr sz="3000" b="1" i="0" dirty="0">
-                <a:solidFill>
-                  <a:srgbClr val="1F385C"/>
-                </a:solidFill>
-              </a:rPr>
-              <a:t>Structural signal</a:t>
+              <a:rPr sz="3000" b="1" i="0">
+                <a:solidFill>
+                  <a:srgbClr val="1F385C"/>
+                </a:solidFill>
+              </a:rPr>
+              <a:t>Step 200</a:t>
             </a:r>
           </a:p>
         </p:txBody>
@@ -9741,7 +9951,7 @@
                   <a:srgbClr val="262B33"/>
                 </a:solidFill>
               </a:rPr>
-              <a:t>Final stage colored by node </a:t>
+              <a:t>Cluster structure already largely in place: </a:t>
             </a:r>
             <a:r>
               <a:rPr sz="1600" b="1" i="0" dirty="0">
@@ -9749,38 +9959,14 @@
                   <a:srgbClr val="1F385C"/>
                 </a:solidFill>
               </a:rPr>
-              <a:t>degree</a:t>
-            </a:r>
-            <a:r>
-              <a:rPr sz="1600" b="0" i="0" dirty="0">
-                <a:solidFill>
-                  <a:srgbClr val="262B33"/>
-                </a:solidFill>
-              </a:rPr>
-              <a:t> instead of split: a direct check of Theorem 1's structural</a:t>
-            </a:r>
-            <a:r>
-              <a:rPr lang="it-IT" sz="1600" b="0" i="0" dirty="0">
-                <a:solidFill>
-                  <a:srgbClr val="262B33"/>
-                </a:solidFill>
-              </a:rPr>
-              <a:t> </a:t>
-            </a:r>
-            <a:r>
-              <a:rPr sz="1600" b="0" i="0" dirty="0">
-                <a:solidFill>
-                  <a:srgbClr val="262B33"/>
-                </a:solidFill>
-              </a:rPr>
-              <a:t>signal claim</a:t>
+              <a:t>~85× fewer steps than a full epoch</a:t>
             </a:r>
           </a:p>
         </p:txBody>
       </p:sp>
       <p:pic>
         <p:nvPicPr>
-          <p:cNvPr id="5" name="Picture 4" descr="slide19_img19.png"/>
+          <p:cNvPr id="5" name="Picture 4" descr="slide17_img15.png"/>
           <p:cNvPicPr>
             <a:picLocks noChangeAspect="1"/>
           </p:cNvPicPr>
@@ -9794,8 +9980,8 @@
         </p:blipFill>
         <p:spPr>
           <a:xfrm>
-            <a:off x="662140" y="2560265"/>
-            <a:ext cx="5183029" cy="3520548"/>
+            <a:off x="864222" y="2377440"/>
+            <a:ext cx="4867244" cy="3886200"/>
           </a:xfrm>
           <a:prstGeom prst="rect">
             <a:avLst/>
@@ -9804,7 +9990,7 @@
       </p:pic>
       <p:pic>
         <p:nvPicPr>
-          <p:cNvPr id="6" name="Picture 5" descr="slide19_img20.png"/>
+          <p:cNvPr id="6" name="Picture 5" descr="slide17_img16.png"/>
           <p:cNvPicPr>
             <a:picLocks noChangeAspect="1"/>
           </p:cNvPicPr>
@@ -9818,8 +10004,8 @@
         </p:blipFill>
         <p:spPr>
           <a:xfrm>
-            <a:off x="6347307" y="2560265"/>
-            <a:ext cx="5183029" cy="3520548"/>
+            <a:off x="6232664" y="2377440"/>
+            <a:ext cx="5095100" cy="3886200"/>
           </a:xfrm>
           <a:prstGeom prst="rect">
             <a:avLst/>
@@ -9855,7 +10041,7 @@
                   <a:srgbClr val="9AA5B1"/>
                 </a:solidFill>
               </a:rPr>
-              <a:t>25</a:t>
+              <a:t>23</a:t>
             </a:r>
           </a:p>
         </p:txBody>
@@ -9914,7 +10100,7 @@
                   <a:srgbClr val="1BAF7A"/>
                 </a:solidFill>
               </a:rPr>
-              <a:t>12 · RESULTS V</a:t>
+              <a:t>11 · EMBEDDING EVOLUTION</a:t>
             </a:r>
           </a:p>
         </p:txBody>
@@ -9928,7 +10114,7 @@
         <p:spPr>
           <a:xfrm>
             <a:off x="685800" y="786384"/>
-            <a:ext cx="10820095" cy="434093"/>
+            <a:ext cx="10820095" cy="868680"/>
           </a:xfrm>
           <a:prstGeom prst="rect">
             <a:avLst/>
@@ -9947,12 +10133,28 @@
               </a:lnSpc>
             </a:pPr>
             <a:r>
-              <a:rPr sz="2800" b="1" i="0" dirty="0">
-                <a:solidFill>
-                  <a:srgbClr val="1F385C"/>
-                </a:solidFill>
-              </a:rPr>
-              <a:t>K-sensitivity</a:t>
+              <a:rPr sz="3000" b="1" i="0" dirty="0">
+                <a:solidFill>
+                  <a:srgbClr val="1F385C"/>
+                </a:solidFill>
+              </a:rPr>
+              <a:t>Step 17</a:t>
+            </a:r>
+            <a:r>
+              <a:rPr lang="it-IT" sz="3000" b="1" i="0" dirty="0">
+                <a:solidFill>
+                  <a:srgbClr val="1F385C"/>
+                </a:solidFill>
+              </a:rPr>
+              <a:t>,</a:t>
+            </a:r>
+            <a:r>
+              <a:rPr sz="3000" b="1" i="0" dirty="0">
+                <a:solidFill>
+                  <a:srgbClr val="1F385C"/>
+                </a:solidFill>
+              </a:rPr>
+              <a:t>050</a:t>
             </a:r>
           </a:p>
         </p:txBody>
@@ -9965,8 +10167,8 @@
         </p:nvSpPr>
         <p:spPr>
           <a:xfrm>
-            <a:off x="685800" y="2297305"/>
-            <a:ext cx="3931920" cy="1634615"/>
+            <a:off x="685800" y="1783080"/>
+            <a:ext cx="10820095" cy="246221"/>
           </a:xfrm>
           <a:prstGeom prst="rect">
             <a:avLst/>
@@ -9979,120 +10181,29 @@
           </a:bodyPr>
           <a:lstStyle/>
           <a:p>
-            <a:pPr algn="l">
-              <a:lnSpc>
-                <a:spcPct val="115000"/>
-              </a:lnSpc>
-              <a:spcAft>
-                <a:spcPts val="1600"/>
-              </a:spcAft>
-            </a:pPr>
-            <a:r>
-              <a:rPr sz="1400" b="0" i="0" dirty="0">
-                <a:solidFill>
-                  <a:srgbClr val="1BAF7A"/>
-                </a:solidFill>
-              </a:rPr>
-              <a:t>●   </a:t>
-            </a:r>
-            <a:r>
-              <a:rPr sz="1400" b="1" i="0" dirty="0">
-                <a:solidFill>
-                  <a:srgbClr val="1F385C"/>
-                </a:solidFill>
-              </a:rPr>
-              <a:t>K=2 beats K=1</a:t>
-            </a:r>
-            <a:r>
-              <a:rPr sz="1400" b="0" i="0" dirty="0">
-                <a:solidFill>
-                  <a:srgbClr val="262B33"/>
-                </a:solidFill>
-              </a:rPr>
-              <a:t>: 0.585 vs. 0.472 F1</a:t>
-            </a:r>
-          </a:p>
-          <a:p>
-            <a:pPr algn="l">
-              <a:lnSpc>
-                <a:spcPct val="115000"/>
-              </a:lnSpc>
-              <a:spcAft>
-                <a:spcPts val="1600"/>
-              </a:spcAft>
-            </a:pPr>
-            <a:r>
-              <a:rPr sz="1400" b="0" i="0" dirty="0">
-                <a:solidFill>
-                  <a:srgbClr val="1BAF7A"/>
-                </a:solidFill>
-              </a:rPr>
-              <a:t>●   </a:t>
-            </a:r>
-            <a:r>
-              <a:rPr sz="1400" b="1" i="0" dirty="0">
-                <a:solidFill>
-                  <a:srgbClr val="1F385C"/>
-                </a:solidFill>
-              </a:rPr>
-              <a:t>K=3 no better</a:t>
-            </a:r>
-            <a:r>
-              <a:rPr sz="1400" b="0" i="0" dirty="0">
-                <a:solidFill>
-                  <a:srgbClr val="262B33"/>
-                </a:solidFill>
-              </a:rPr>
-              <a:t>: 0.575, consistent with the paper's “marginal returns beyond K=2”</a:t>
-            </a:r>
-          </a:p>
-          <a:p>
-            <a:pPr algn="l">
-              <a:lnSpc>
-                <a:spcPct val="115000"/>
-              </a:lnSpc>
-              <a:spcAft>
-                <a:spcPts val="0"/>
-              </a:spcAft>
-            </a:pPr>
-            <a:r>
-              <a:rPr sz="1400" b="0" i="0" dirty="0">
-                <a:solidFill>
-                  <a:srgbClr val="1BAF7A"/>
-                </a:solidFill>
-              </a:rPr>
-              <a:t>●   </a:t>
-            </a:r>
-            <a:r>
-              <a:rPr sz="1400" b="0" i="0" dirty="0">
-                <a:solidFill>
-                  <a:srgbClr val="262B33"/>
-                </a:solidFill>
-              </a:rPr>
-              <a:t>Same panel also shows the </a:t>
-            </a:r>
-            <a:r>
-              <a:rPr sz="1400" b="1" i="0" dirty="0">
-                <a:solidFill>
-                  <a:srgbClr val="1F385C"/>
-                </a:solidFill>
-              </a:rPr>
-              <a:t>runtime cost</a:t>
-            </a:r>
-            <a:r>
-              <a:rPr sz="1400" b="0" i="0" dirty="0">
-                <a:solidFill>
-                  <a:srgbClr val="262B33"/>
-                </a:solidFill>
-              </a:rPr>
-              <a:t> growing with K</a:t>
+            <a:pPr algn="ctr"/>
+            <a:r>
+              <a:rPr sz="1600" b="0" i="0" dirty="0">
+                <a:solidFill>
+                  <a:srgbClr val="262B33"/>
+                </a:solidFill>
+              </a:rPr>
+              <a:t>Final stage (~1 full epoch): </a:t>
+            </a:r>
+            <a:r>
+              <a:rPr sz="1600" b="1" i="0" dirty="0">
+                <a:solidFill>
+                  <a:srgbClr val="1F385C"/>
+                </a:solidFill>
+              </a:rPr>
+              <a:t>training mostly refines distances/density from here</a:t>
             </a:r>
           </a:p>
         </p:txBody>
       </p:sp>
       <p:pic>
         <p:nvPicPr>
-          <p:cNvPr id="5" name="Picture 4" descr="slide20_img21.png"/>
+          <p:cNvPr id="5" name="Picture 4" descr="slide18_img17.png"/>
           <p:cNvPicPr>
             <a:picLocks noChangeAspect="1"/>
           </p:cNvPicPr>
@@ -10106,17 +10217,41 @@
         </p:blipFill>
         <p:spPr>
           <a:xfrm>
-            <a:off x="5290032" y="1783080"/>
-            <a:ext cx="5909310" cy="4297680"/>
+            <a:off x="864222" y="2377440"/>
+            <a:ext cx="4867244" cy="3886200"/>
           </a:xfrm>
           <a:prstGeom prst="rect">
             <a:avLst/>
           </a:prstGeom>
         </p:spPr>
       </p:pic>
-      <p:sp>
-        <p:nvSpPr>
-          <p:cNvPr id="6" name="TextBox 5"/>
+      <p:pic>
+        <p:nvPicPr>
+          <p:cNvPr id="6" name="Picture 5" descr="slide18_img18.png"/>
+          <p:cNvPicPr>
+            <a:picLocks noChangeAspect="1"/>
+          </p:cNvPicPr>
+          <p:nvPr/>
+        </p:nvPicPr>
+        <p:blipFill>
+          <a:blip r:embed="rId3"/>
+          <a:stretch>
+            <a:fillRect/>
+          </a:stretch>
+        </p:blipFill>
+        <p:spPr>
+          <a:xfrm>
+            <a:off x="6232664" y="2377440"/>
+            <a:ext cx="5095100" cy="3886200"/>
+          </a:xfrm>
+          <a:prstGeom prst="rect">
+            <a:avLst/>
+          </a:prstGeom>
+        </p:spPr>
+      </p:pic>
+      <p:sp>
+        <p:nvSpPr>
+          <p:cNvPr id="7" name="TextBox 6"/>
           <p:cNvSpPr txBox="1"/>
           <p:nvPr/>
         </p:nvSpPr>
@@ -10143,7 +10278,7 @@
                   <a:srgbClr val="9AA5B1"/>
                 </a:solidFill>
               </a:rPr>
-              <a:t>26</a:t>
+              <a:t>24</a:t>
             </a:r>
           </a:p>
         </p:txBody>
@@ -10202,7 +10337,7 @@
                   <a:srgbClr val="1BAF7A"/>
                 </a:solidFill>
               </a:rPr>
-              <a:t>13 · RESULTS VI</a:t>
+              <a:t>11 · EMBEDDING EVOLUTION</a:t>
             </a:r>
           </a:p>
         </p:txBody>
@@ -10216,7 +10351,7 @@
         <p:spPr>
           <a:xfrm>
             <a:off x="685800" y="786384"/>
-            <a:ext cx="10820095" cy="868680"/>
+            <a:ext cx="10820095" cy="465127"/>
           </a:xfrm>
           <a:prstGeom prst="rect">
             <a:avLst/>
@@ -10235,12 +10370,12 @@
               </a:lnSpc>
             </a:pPr>
             <a:r>
-              <a:rPr sz="2800" b="1" i="0" dirty="0">
-                <a:solidFill>
-                  <a:srgbClr val="1F385C"/>
-                </a:solidFill>
-              </a:rPr>
-              <a:t>Noise robustness (Theorem 1, empirical)</a:t>
+              <a:rPr sz="3000" b="1" i="0" dirty="0">
+                <a:solidFill>
+                  <a:srgbClr val="1F385C"/>
+                </a:solidFill>
+              </a:rPr>
+              <a:t>Structural signal</a:t>
             </a:r>
           </a:p>
         </p:txBody>
@@ -10253,8 +10388,8 @@
         </p:nvSpPr>
         <p:spPr>
           <a:xfrm>
-            <a:off x="685800" y="2054183"/>
-            <a:ext cx="3931920" cy="1882375"/>
+            <a:off x="685800" y="1783080"/>
+            <a:ext cx="10820095" cy="246221"/>
           </a:xfrm>
           <a:prstGeom prst="rect">
             <a:avLst/>
@@ -10267,128 +10402,53 @@
           </a:bodyPr>
           <a:lstStyle/>
           <a:p>
-            <a:pPr algn="l">
-              <a:lnSpc>
-                <a:spcPct val="115000"/>
-              </a:lnSpc>
-              <a:spcAft>
-                <a:spcPts val="1600"/>
-              </a:spcAft>
-            </a:pPr>
-            <a:r>
-              <a:rPr sz="1400" b="0" i="0" dirty="0">
-                <a:solidFill>
-                  <a:srgbClr val="1BAF7A"/>
-                </a:solidFill>
-              </a:rPr>
-              <a:t>●   </a:t>
-            </a:r>
-            <a:r>
-              <a:rPr sz="1400" b="1" i="0" dirty="0" err="1">
-                <a:solidFill>
-                  <a:srgbClr val="1F385C"/>
-                </a:solidFill>
-              </a:rPr>
-              <a:t>GraphSAGE</a:t>
-            </a:r>
-            <a:r>
-              <a:rPr sz="1400" b="1" i="0" dirty="0">
-                <a:solidFill>
-                  <a:srgbClr val="1F385C"/>
-                </a:solidFill>
-              </a:rPr>
-              <a:t>-pool</a:t>
-            </a:r>
-            <a:r>
-              <a:rPr sz="1400" b="0" i="0" dirty="0">
-                <a:solidFill>
-                  <a:srgbClr val="262B33"/>
-                </a:solidFill>
-              </a:rPr>
-              <a:t> stays above both GCN and the raw-features baseline at every noise level</a:t>
-            </a:r>
-          </a:p>
-          <a:p>
-            <a:pPr algn="l">
-              <a:lnSpc>
-                <a:spcPct val="115000"/>
-              </a:lnSpc>
-              <a:spcAft>
-                <a:spcPts val="1600"/>
-              </a:spcAft>
-            </a:pPr>
-            <a:r>
-              <a:rPr sz="1400" b="0" i="0" dirty="0">
-                <a:solidFill>
-                  <a:srgbClr val="1BAF7A"/>
-                </a:solidFill>
-              </a:rPr>
-              <a:t>●   </a:t>
-            </a:r>
-            <a:r>
-              <a:rPr sz="1400" b="1" i="0" dirty="0">
-                <a:solidFill>
-                  <a:srgbClr val="1F385C"/>
-                </a:solidFill>
-              </a:rPr>
-              <a:t>GCN falls below raw features</a:t>
-            </a:r>
-            <a:r>
-              <a:rPr sz="1400" b="0" i="0" dirty="0">
-                <a:solidFill>
-                  <a:srgbClr val="262B33"/>
-                </a:solidFill>
-              </a:rPr>
-              <a:t> at full noise (0.389 vs. 0.393)</a:t>
-            </a:r>
-          </a:p>
-          <a:p>
-            <a:pPr algn="l">
-              <a:lnSpc>
-                <a:spcPct val="115000"/>
-              </a:lnSpc>
-              <a:spcAft>
-                <a:spcPts val="0"/>
-              </a:spcAft>
-            </a:pPr>
-            <a:r>
-              <a:rPr sz="1400" b="0" i="0" dirty="0">
-                <a:solidFill>
-                  <a:srgbClr val="1BAF7A"/>
-                </a:solidFill>
-              </a:rPr>
-              <a:t>●   </a:t>
-            </a:r>
-            <a:r>
-              <a:rPr sz="1400" b="0" i="0" dirty="0">
-                <a:solidFill>
-                  <a:srgbClr val="262B33"/>
-                </a:solidFill>
-              </a:rPr>
-              <a:t>Exactly the structural-reliance gap </a:t>
-            </a:r>
-            <a:r>
-              <a:rPr sz="1400" b="1" i="0" dirty="0">
-                <a:solidFill>
-                  <a:srgbClr val="1F385C"/>
-                </a:solidFill>
-              </a:rPr>
-              <a:t>Theorem 1</a:t>
-            </a:r>
-            <a:r>
-              <a:rPr sz="1400" b="0" i="0" dirty="0">
-                <a:solidFill>
-                  <a:srgbClr val="262B33"/>
-                </a:solidFill>
-              </a:rPr>
-              <a:t> predicts</a:t>
+            <a:pPr algn="ctr"/>
+            <a:r>
+              <a:rPr sz="1600" b="0" i="0" dirty="0">
+                <a:solidFill>
+                  <a:srgbClr val="262B33"/>
+                </a:solidFill>
+              </a:rPr>
+              <a:t>Final stage colored by node </a:t>
+            </a:r>
+            <a:r>
+              <a:rPr sz="1600" b="1" i="0" dirty="0">
+                <a:solidFill>
+                  <a:srgbClr val="1F385C"/>
+                </a:solidFill>
+              </a:rPr>
+              <a:t>degree</a:t>
+            </a:r>
+            <a:r>
+              <a:rPr sz="1600" b="0" i="0" dirty="0">
+                <a:solidFill>
+                  <a:srgbClr val="262B33"/>
+                </a:solidFill>
+              </a:rPr>
+              <a:t> instead of split: a direct check of Theorem 1's structural</a:t>
+            </a:r>
+            <a:r>
+              <a:rPr lang="it-IT" sz="1600" b="0" i="0" dirty="0">
+                <a:solidFill>
+                  <a:srgbClr val="262B33"/>
+                </a:solidFill>
+              </a:rPr>
+              <a:t> </a:t>
+            </a:r>
+            <a:r>
+              <a:rPr sz="1600" b="0" i="0" dirty="0">
+                <a:solidFill>
+                  <a:srgbClr val="262B33"/>
+                </a:solidFill>
+              </a:rPr>
+              <a:t>signal claim</a:t>
             </a:r>
           </a:p>
         </p:txBody>
       </p:sp>
       <p:pic>
         <p:nvPicPr>
-          <p:cNvPr id="5" name="Picture 4" descr="slide21_img22.png"/>
+          <p:cNvPr id="5" name="Picture 4" descr="slide19_img19.png"/>
           <p:cNvPicPr>
             <a:picLocks noChangeAspect="1"/>
           </p:cNvPicPr>
@@ -10402,17 +10462,41 @@
         </p:blipFill>
         <p:spPr>
           <a:xfrm>
-            <a:off x="5141762" y="1783080"/>
-            <a:ext cx="6205849" cy="4297680"/>
+            <a:off x="662140" y="2560265"/>
+            <a:ext cx="5183029" cy="3520548"/>
           </a:xfrm>
           <a:prstGeom prst="rect">
             <a:avLst/>
           </a:prstGeom>
         </p:spPr>
       </p:pic>
-      <p:sp>
-        <p:nvSpPr>
-          <p:cNvPr id="6" name="TextBox 5"/>
+      <p:pic>
+        <p:nvPicPr>
+          <p:cNvPr id="6" name="Picture 5" descr="slide19_img20.png"/>
+          <p:cNvPicPr>
+            <a:picLocks noChangeAspect="1"/>
+          </p:cNvPicPr>
+          <p:nvPr/>
+        </p:nvPicPr>
+        <p:blipFill>
+          <a:blip r:embed="rId3"/>
+          <a:stretch>
+            <a:fillRect/>
+          </a:stretch>
+        </p:blipFill>
+        <p:spPr>
+          <a:xfrm>
+            <a:off x="6347307" y="2560265"/>
+            <a:ext cx="5183029" cy="3520548"/>
+          </a:xfrm>
+          <a:prstGeom prst="rect">
+            <a:avLst/>
+          </a:prstGeom>
+        </p:spPr>
+      </p:pic>
+      <p:sp>
+        <p:nvSpPr>
+          <p:cNvPr id="7" name="TextBox 6"/>
           <p:cNvSpPr txBox="1"/>
           <p:nvPr/>
         </p:nvSpPr>
@@ -10439,7 +10523,7 @@
                   <a:srgbClr val="9AA5B1"/>
                 </a:solidFill>
               </a:rPr>
-              <a:t>28</a:t>
+              <a:t>25</a:t>
             </a:r>
           </a:p>
         </p:txBody>
@@ -10498,7 +10582,7 @@
                   <a:srgbClr val="1BAF7A"/>
                 </a:solidFill>
               </a:rPr>
-              <a:t>14 · DISCUSSION &amp; CONCLUSIONS</a:t>
+              <a:t>12 · RESULTS V</a:t>
             </a:r>
           </a:p>
         </p:txBody>
@@ -10512,7 +10596,7 @@
         <p:spPr>
           <a:xfrm>
             <a:off x="685800" y="786384"/>
-            <a:ext cx="10820095" cy="868680"/>
+            <a:ext cx="10820095" cy="434093"/>
           </a:xfrm>
           <a:prstGeom prst="rect">
             <a:avLst/>
@@ -10531,12 +10615,12 @@
               </a:lnSpc>
             </a:pPr>
             <a:r>
-              <a:rPr sz="3000" b="1" i="0" dirty="0">
-                <a:solidFill>
-                  <a:srgbClr val="1F385C"/>
-                </a:solidFill>
-              </a:rPr>
-              <a:t>What this reproduction shows</a:t>
+              <a:rPr sz="2800" b="1" i="0" dirty="0">
+                <a:solidFill>
+                  <a:srgbClr val="1F385C"/>
+                </a:solidFill>
+              </a:rPr>
+              <a:t>K-sensitivity</a:t>
             </a:r>
           </a:p>
         </p:txBody>
@@ -10549,8 +10633,8 @@
         </p:nvSpPr>
         <p:spPr>
           <a:xfrm>
-            <a:off x="685800" y="2057400"/>
-            <a:ext cx="10820095" cy="1963358"/>
+            <a:off x="685800" y="2297305"/>
+            <a:ext cx="3931920" cy="1634615"/>
           </a:xfrm>
           <a:prstGeom prst="rect">
             <a:avLst/>
@@ -10568,11 +10652,11 @@
                 <a:spcPct val="115000"/>
               </a:lnSpc>
               <a:spcAft>
-                <a:spcPts val="2200"/>
+                <a:spcPts val="1600"/>
               </a:spcAft>
             </a:pPr>
             <a:r>
-              <a:rPr sz="1600" b="0" i="0" dirty="0">
+              <a:rPr sz="1400" b="0" i="0" dirty="0">
                 <a:solidFill>
                   <a:srgbClr val="1BAF7A"/>
                 </a:solidFill>
@@ -10580,60 +10664,20 @@
               <a:t>●   </a:t>
             </a:r>
             <a:r>
-              <a:rPr sz="1600" b="0" i="0" dirty="0">
-                <a:solidFill>
-                  <a:srgbClr val="262B33"/>
-                </a:solidFill>
-              </a:rPr>
-              <a:t>Qualitative ordering </a:t>
-            </a:r>
-            <a:r>
-              <a:rPr sz="1600" b="1" i="0" dirty="0">
-                <a:solidFill>
-                  <a:srgbClr val="1F385C"/>
-                </a:solidFill>
-              </a:rPr>
-              <a:t>survives the scale</a:t>
-            </a:r>
-            <a:r>
-              <a:rPr lang="it-IT" sz="1600" b="1" i="0" dirty="0">
-                <a:solidFill>
-                  <a:srgbClr val="1F385C"/>
-                </a:solidFill>
-              </a:rPr>
-              <a:t> </a:t>
-            </a:r>
-            <a:r>
-              <a:rPr sz="1600" b="1" i="0" dirty="0">
-                <a:solidFill>
-                  <a:srgbClr val="1F385C"/>
-                </a:solidFill>
-              </a:rPr>
-              <a:t>down</a:t>
-            </a:r>
-            <a:r>
-              <a:rPr sz="1600" b="0" i="0" dirty="0">
-                <a:solidFill>
-                  <a:srgbClr val="262B33"/>
-                </a:solidFill>
-              </a:rPr>
-              <a:t>: </a:t>
-            </a:r>
-            <a:r>
-              <a:rPr sz="1600" b="0" i="0" dirty="0" err="1">
-                <a:solidFill>
-                  <a:srgbClr val="262B33"/>
-                </a:solidFill>
-              </a:rPr>
-              <a:t>GraphSAGE</a:t>
-            </a:r>
-            <a:r>
-              <a:rPr sz="1600" b="0" i="0" dirty="0">
-                <a:solidFill>
-                  <a:srgbClr val="262B33"/>
-                </a:solidFill>
-              </a:rPr>
-              <a:t> ≫ Raw features &gt; Random, supervised ≥ unsupervised — GCN is weakest in the supervised setting, but is actually the strongest unsupervised GraphSAGE variant reproduced here</a:t>
+              <a:rPr sz="1400" b="1" i="0" dirty="0">
+                <a:solidFill>
+                  <a:srgbClr val="1F385C"/>
+                </a:solidFill>
+              </a:rPr>
+              <a:t>K=2 beats K=1</a:t>
+            </a:r>
+            <a:r>
+              <a:rPr sz="1400" b="0" i="0" dirty="0">
+                <a:solidFill>
+                  <a:srgbClr val="262B33"/>
+                </a:solidFill>
+              </a:rPr>
+              <a:t>: 0.585 vs. 0.472 F1</a:t>
             </a:r>
           </a:p>
           <a:p>
@@ -10642,11 +10686,11 @@
                 <a:spcPct val="115000"/>
               </a:lnSpc>
               <a:spcAft>
-                <a:spcPts val="2200"/>
+                <a:spcPts val="1600"/>
               </a:spcAft>
             </a:pPr>
             <a:r>
-              <a:rPr sz="1600" b="0" i="0" dirty="0">
+              <a:rPr sz="1400" b="0" i="0" dirty="0">
                 <a:solidFill>
                   <a:srgbClr val="1BAF7A"/>
                 </a:solidFill>
@@ -10654,12 +10698,20 @@
               <a:t>●   </a:t>
             </a:r>
             <a:r>
-              <a:rPr sz="1600" b="0" i="0" dirty="0">
-                <a:solidFill>
-                  <a:srgbClr val="262B33"/>
-                </a:solidFill>
-              </a:rPr>
-              <a:t>Numerical gaps vs. paper explained by: reduced hyperparameter grid, fewer seeds, TensorFlow version drift, different hardware (1× RTX 2060 SUPER vs. 4× Titan X Pascal)</a:t>
+              <a:rPr sz="1400" b="1" i="0" dirty="0">
+                <a:solidFill>
+                  <a:srgbClr val="1F385C"/>
+                </a:solidFill>
+              </a:rPr>
+              <a:t>K=3 no better</a:t>
+            </a:r>
+            <a:r>
+              <a:rPr sz="1400" b="0" i="0" dirty="0">
+                <a:solidFill>
+                  <a:srgbClr val="262B33"/>
+                </a:solidFill>
+              </a:rPr>
+              <a:t>: 0.575, consistent with the paper's “marginal returns beyond K=2”</a:t>
             </a:r>
           </a:p>
           <a:p>
@@ -10672,7 +10724,7 @@
               </a:spcAft>
             </a:pPr>
             <a:r>
-              <a:rPr sz="1600" b="0" i="0" dirty="0">
+              <a:rPr sz="1400" b="0" i="0" dirty="0">
                 <a:solidFill>
                   <a:srgbClr val="1BAF7A"/>
                 </a:solidFill>
@@ -10680,99 +10732,59 @@
               <a:t>●   </a:t>
             </a:r>
             <a:r>
-              <a:rPr sz="1600" b="0" i="0" dirty="0">
-                <a:solidFill>
-                  <a:srgbClr val="262B33"/>
-                </a:solidFill>
-              </a:rPr>
-              <a:t>Both theoretical claims (</a:t>
-            </a:r>
-            <a:r>
-              <a:rPr sz="1600" b="1" i="0" dirty="0">
-                <a:solidFill>
-                  <a:srgbClr val="1F385C"/>
-                </a:solidFill>
-              </a:rPr>
-              <a:t>K</a:t>
-            </a:r>
-            <a:r>
-              <a:rPr lang="it-IT" sz="1600" b="1" i="0" dirty="0">
-                <a:solidFill>
-                  <a:srgbClr val="1F385C"/>
-                </a:solidFill>
-              </a:rPr>
-              <a:t> </a:t>
-            </a:r>
-            <a:r>
-              <a:rPr sz="1600" b="1" i="0" dirty="0">
-                <a:solidFill>
-                  <a:srgbClr val="1F385C"/>
-                </a:solidFill>
-              </a:rPr>
-              <a:t>sensitivity</a:t>
-            </a:r>
-            <a:r>
-              <a:rPr sz="1600" b="0" i="0" dirty="0">
-                <a:solidFill>
-                  <a:srgbClr val="262B33"/>
-                </a:solidFill>
-              </a:rPr>
-              <a:t> and </a:t>
-            </a:r>
-            <a:r>
-              <a:rPr sz="1600" b="1" i="0" dirty="0">
-                <a:solidFill>
-                  <a:srgbClr val="1F385C"/>
-                </a:solidFill>
-              </a:rPr>
-              <a:t>noise</a:t>
-            </a:r>
-            <a:r>
-              <a:rPr lang="it-IT" sz="1600" b="1" i="0" dirty="0">
-                <a:solidFill>
-                  <a:srgbClr val="1F385C"/>
-                </a:solidFill>
-              </a:rPr>
-              <a:t> </a:t>
-            </a:r>
-            <a:r>
-              <a:rPr sz="1600" b="1" i="0" dirty="0">
-                <a:solidFill>
-                  <a:srgbClr val="1F385C"/>
-                </a:solidFill>
-              </a:rPr>
-              <a:t>robustness</a:t>
-            </a:r>
-            <a:r>
-              <a:rPr sz="1600" b="0" i="0" dirty="0">
-                <a:solidFill>
-                  <a:srgbClr val="262B33"/>
-                </a:solidFill>
-              </a:rPr>
-              <a:t>) independently </a:t>
-            </a:r>
-            <a:r>
-              <a:rPr sz="1600" b="1" i="0" dirty="0">
-                <a:solidFill>
-                  <a:srgbClr val="1F385C"/>
-                </a:solidFill>
-              </a:rPr>
-              <a:t>verified on PPI</a:t>
-            </a:r>
-            <a:r>
-              <a:rPr sz="1600" b="0" i="0" dirty="0">
-                <a:solidFill>
-                  <a:srgbClr val="262B33"/>
-                </a:solidFill>
-              </a:rPr>
-              <a:t>, not just asserted from the paper</a:t>
-            </a:r>
-          </a:p>
-        </p:txBody>
-      </p:sp>
-      <p:sp>
-        <p:nvSpPr>
-          <p:cNvPr id="5" name="TextBox 4"/>
+              <a:rPr sz="1400" b="0" i="0" dirty="0">
+                <a:solidFill>
+                  <a:srgbClr val="262B33"/>
+                </a:solidFill>
+              </a:rPr>
+              <a:t>Same panel also shows the </a:t>
+            </a:r>
+            <a:r>
+              <a:rPr sz="1400" b="1" i="0" dirty="0">
+                <a:solidFill>
+                  <a:srgbClr val="1F385C"/>
+                </a:solidFill>
+              </a:rPr>
+              <a:t>runtime cost</a:t>
+            </a:r>
+            <a:r>
+              <a:rPr sz="1400" b="0" i="0" dirty="0">
+                <a:solidFill>
+                  <a:srgbClr val="262B33"/>
+                </a:solidFill>
+              </a:rPr>
+              <a:t> growing with K</a:t>
+            </a:r>
+          </a:p>
+        </p:txBody>
+      </p:sp>
+      <p:pic>
+        <p:nvPicPr>
+          <p:cNvPr id="5" name="Picture 4" descr="slide20_img21.png"/>
+          <p:cNvPicPr>
+            <a:picLocks noChangeAspect="1"/>
+          </p:cNvPicPr>
+          <p:nvPr/>
+        </p:nvPicPr>
+        <p:blipFill>
+          <a:blip r:embed="rId2"/>
+          <a:stretch>
+            <a:fillRect/>
+          </a:stretch>
+        </p:blipFill>
+        <p:spPr>
+          <a:xfrm>
+            <a:off x="5290032" y="1783080"/>
+            <a:ext cx="5909310" cy="4297680"/>
+          </a:xfrm>
+          <a:prstGeom prst="rect">
+            <a:avLst/>
+          </a:prstGeom>
+        </p:spPr>
+      </p:pic>
+      <p:sp>
+        <p:nvSpPr>
+          <p:cNvPr id="6" name="TextBox 5"/>
           <p:cNvSpPr txBox="1"/>
           <p:nvPr/>
         </p:nvSpPr>
@@ -10799,7 +10811,7 @@
                   <a:srgbClr val="9AA5B1"/>
                 </a:solidFill>
               </a:rPr>
-              <a:t>29</a:t>
+              <a:t>26</a:t>
             </a:r>
           </a:p>
         </p:txBody>
@@ -10831,59 +10843,14 @@
       </p:grpSpPr>
       <p:sp>
         <p:nvSpPr>
-          <p:cNvPr id="2" name="Rectangle 1"/>
-          <p:cNvSpPr/>
-          <p:nvPr/>
-        </p:nvSpPr>
-        <p:spPr>
-          <a:xfrm>
-            <a:off x="0" y="0"/>
-            <a:ext cx="82296" cy="6858000"/>
-          </a:xfrm>
-          <a:prstGeom prst="rect">
-            <a:avLst/>
-          </a:prstGeom>
-          <a:solidFill>
-            <a:srgbClr val="1BAF7A"/>
-          </a:solidFill>
-          <a:ln>
-            <a:noFill/>
-          </a:ln>
-          <a:effectLst/>
-        </p:spPr>
-        <p:style>
-          <a:lnRef idx="1">
-            <a:schemeClr val="accent1"/>
-          </a:lnRef>
-          <a:fillRef idx="3">
-            <a:schemeClr val="accent1"/>
-          </a:fillRef>
-          <a:effectRef idx="2">
-            <a:schemeClr val="accent1"/>
-          </a:effectRef>
-          <a:fontRef idx="minor">
-            <a:schemeClr val="lt1"/>
-          </a:fontRef>
-        </p:style>
-        <p:txBody>
-          <a:bodyPr rtlCol="0" anchor="ctr"/>
-          <a:lstStyle/>
-          <a:p>
-            <a:pPr algn="ctr"/>
-            <a:endParaRPr/>
-          </a:p>
-        </p:txBody>
-      </p:sp>
-      <p:sp>
-        <p:nvSpPr>
-          <p:cNvPr id="3" name="TextBox 2"/>
+          <p:cNvPr id="2" name="TextBox 1"/>
           <p:cNvSpPr txBox="1"/>
           <p:nvPr/>
         </p:nvSpPr>
         <p:spPr>
           <a:xfrm>
-            <a:off x="0" y="2880360"/>
-            <a:ext cx="12191695" cy="1097280"/>
+            <a:off x="685800" y="457200"/>
+            <a:ext cx="10820095" cy="292608"/>
           </a:xfrm>
           <a:prstGeom prst="rect">
             <a:avLst/>
@@ -10896,28 +10863,28 @@
           </a:bodyPr>
           <a:lstStyle/>
           <a:p>
-            <a:pPr algn="ctr"/>
-            <a:r>
-              <a:rPr sz="4600" b="1" i="0">
-                <a:solidFill>
-                  <a:srgbClr val="1F385C"/>
-                </a:solidFill>
-              </a:rPr>
-              <a:t>Thank You</a:t>
-            </a:r>
-          </a:p>
-        </p:txBody>
-      </p:sp>
-      <p:sp>
-        <p:nvSpPr>
-          <p:cNvPr id="4" name="TextBox 3"/>
+            <a:pPr algn="l"/>
+            <a:r>
+              <a:rPr sz="1300" b="1" i="0" dirty="0">
+                <a:solidFill>
+                  <a:srgbClr val="1BAF7A"/>
+                </a:solidFill>
+              </a:rPr>
+              <a:t>12 · RESULTS V</a:t>
+            </a:r>
+          </a:p>
+        </p:txBody>
+      </p:sp>
+      <p:sp>
+        <p:nvSpPr>
+          <p:cNvPr id="3" name="TextBox 2"/>
           <p:cNvSpPr txBox="1"/>
           <p:nvPr/>
         </p:nvSpPr>
         <p:spPr>
           <a:xfrm>
-            <a:off x="685800" y="6492240"/>
-            <a:ext cx="8686800" cy="274320"/>
+            <a:off x="685800" y="786384"/>
+            <a:ext cx="10820095" cy="434093"/>
           </a:xfrm>
           <a:prstGeom prst="rect">
             <a:avLst/>
@@ -10930,28 +10897,32 @@
           </a:bodyPr>
           <a:lstStyle/>
           <a:p>
-            <a:pPr algn="l"/>
-            <a:r>
-              <a:rPr sz="1000" b="0" i="1">
-                <a:solidFill>
-                  <a:srgbClr val="9AA5B1"/>
-                </a:solidFill>
-              </a:rPr>
-              <a:t>GraphSAGE on PPI – Scaled Reproduction</a:t>
-            </a:r>
-          </a:p>
-        </p:txBody>
-      </p:sp>
-      <p:sp>
-        <p:nvSpPr>
-          <p:cNvPr id="5" name="TextBox 4"/>
+            <a:pPr algn="l">
+              <a:lnSpc>
+                <a:spcPct val="105000"/>
+              </a:lnSpc>
+            </a:pPr>
+            <a:r>
+              <a:rPr sz="2800" b="1" i="0" dirty="0">
+                <a:solidFill>
+                  <a:srgbClr val="1F385C"/>
+                </a:solidFill>
+              </a:rPr>
+              <a:t>Sample-size sensitivity</a:t>
+            </a:r>
+          </a:p>
+        </p:txBody>
+      </p:sp>
+      <p:sp>
+        <p:nvSpPr>
+          <p:cNvPr id="4" name="TextBox 3"/>
           <p:cNvSpPr txBox="1"/>
           <p:nvPr/>
         </p:nvSpPr>
         <p:spPr>
           <a:xfrm>
-            <a:off x="11292840" y="6492240"/>
-            <a:ext cx="411480" cy="274320"/>
+            <a:off x="685800" y="2297305"/>
+            <a:ext cx="3931920" cy="1634615"/>
           </a:xfrm>
           <a:prstGeom prst="rect">
             <a:avLst/>
@@ -10964,14 +10935,171 @@
           </a:bodyPr>
           <a:lstStyle/>
           <a:p>
+            <a:pPr algn="l">
+              <a:lnSpc>
+                <a:spcPct val="115000"/>
+              </a:lnSpc>
+              <a:spcAft>
+                <a:spcPts val="1600"/>
+              </a:spcAft>
+            </a:pPr>
+            <a:r>
+              <a:rPr sz="1400" b="0" i="0" dirty="0">
+                <a:solidFill>
+                  <a:srgbClr val="1BAF7A"/>
+                </a:solidFill>
+              </a:rPr>
+              <a:t>●   </a:t>
+            </a:r>
+            <a:r>
+              <a:rPr sz="1400" b="1" i="0" dirty="0">
+                <a:solidFill>
+                  <a:srgbClr val="1F385C"/>
+                </a:solidFill>
+              </a:rPr>
+              <a:t>More neighbors help</a:t>
+            </a:r>
+            <a:r>
+              <a:rPr sz="1400" b="0" i="0" dirty="0">
+                <a:solidFill>
+                  <a:srgbClr val="262B33"/>
+                </a:solidFill>
+              </a:rPr>
+              <a:t>: 0.536 → 0.640 F1 from S=5 to S=75</a:t>
+            </a:r>
+          </a:p>
+          <a:p>
+            <a:pPr algn="l">
+              <a:lnSpc>
+                <a:spcPct val="115000"/>
+              </a:lnSpc>
+              <a:spcAft>
+                <a:spcPts val="1600"/>
+              </a:spcAft>
+            </a:pPr>
+            <a:r>
+              <a:rPr sz="1400" b="0" i="0" dirty="0">
+                <a:solidFill>
+                  <a:srgbClr val="1BAF7A"/>
+                </a:solidFill>
+              </a:rPr>
+              <a:t>●   </a:t>
+            </a:r>
+            <a:r>
+              <a:rPr sz="1400" b="1" i="0" dirty="0">
+                <a:solidFill>
+                  <a:srgbClr val="1F385C"/>
+                </a:solidFill>
+              </a:rPr>
+              <a:t>Diminishing returns</a:t>
+            </a:r>
+            <a:r>
+              <a:rPr sz="1400" b="0" i="0" dirty="0">
+                <a:solidFill>
+                  <a:srgbClr val="262B33"/>
+                </a:solidFill>
+              </a:rPr>
+              <a:t>: most of the gain lands by S=25 (0.593); doubling S again to 75 adds only ~0.05 more</a:t>
+            </a:r>
+          </a:p>
+          <a:p>
+            <a:pPr algn="l">
+              <a:lnSpc>
+                <a:spcPct val="115000"/>
+              </a:lnSpc>
+              <a:spcAft>
+                <a:spcPts val="0"/>
+              </a:spcAft>
+            </a:pPr>
+            <a:r>
+              <a:rPr sz="1400" b="0" i="0" dirty="0">
+                <a:solidFill>
+                  <a:srgbClr val="1BAF7A"/>
+                </a:solidFill>
+              </a:rPr>
+              <a:t>●   </a:t>
+            </a:r>
+            <a:r>
+              <a:rPr sz="1400" b="0" i="0" dirty="0">
+                <a:solidFill>
+                  <a:srgbClr val="262B33"/>
+                </a:solidFill>
+              </a:rPr>
+              <a:t>Same panel also shows the </a:t>
+            </a:r>
+            <a:r>
+              <a:rPr sz="1400" b="1" i="0" dirty="0">
+                <a:solidFill>
+                  <a:srgbClr val="1F385C"/>
+                </a:solidFill>
+              </a:rPr>
+              <a:t>runtime cost</a:t>
+            </a:r>
+            <a:r>
+              <a:rPr sz="1400" b="0" i="0" dirty="0">
+                <a:solidFill>
+                  <a:srgbClr val="262B33"/>
+                </a:solidFill>
+              </a:rPr>
+              <a:t> growing with S (0.35 → 0.83 sec/iteration)</a:t>
+            </a:r>
+          </a:p>
+        </p:txBody>
+      </p:sp>
+      <p:pic>
+        <p:nvPicPr>
+          <p:cNvPr id="5" name="Picture 4" descr="ppi_sample_size_sensitivity.png"/>
+          <p:cNvPicPr>
+            <a:picLocks noChangeAspect="1"/>
+          </p:cNvPicPr>
+          <p:nvPr/>
+        </p:nvPicPr>
+        <p:blipFill>
+          <a:blip r:embed="rId2"/>
+          <a:stretch>
+            <a:fillRect/>
+          </a:stretch>
+        </p:blipFill>
+        <p:spPr>
+          <a:xfrm>
+            <a:off x="5290032" y="1783080"/>
+            <a:ext cx="5909310" cy="4297680"/>
+          </a:xfrm>
+          <a:prstGeom prst="rect">
+            <a:avLst/>
+          </a:prstGeom>
+        </p:spPr>
+      </p:pic>
+      <p:sp>
+        <p:nvSpPr>
+          <p:cNvPr id="6" name="TextBox 5"/>
+          <p:cNvSpPr txBox="1"/>
+          <p:nvPr/>
+        </p:nvSpPr>
+        <p:spPr>
+          <a:xfrm>
+            <a:off x="11292840" y="6492240"/>
+            <a:ext cx="411480" cy="274320"/>
+          </a:xfrm>
+          <a:prstGeom prst="rect">
+            <a:avLst/>
+          </a:prstGeom>
+          <a:noFill/>
+        </p:spPr>
+        <p:txBody>
+          <a:bodyPr wrap="square" lIns="0" tIns="0" rIns="0" bIns="0">
+            <a:spAutoFit/>
+          </a:bodyPr>
+          <a:lstStyle/>
+          <a:p>
             <a:pPr algn="r"/>
             <a:r>
-              <a:rPr sz="1100" b="0" i="0">
+              <a:rPr sz="1100" b="0" i="0" dirty="0">
                 <a:solidFill>
                   <a:srgbClr val="9AA5B1"/>
                 </a:solidFill>
               </a:rPr>
-              <a:t>30</a:t>
+              <a:t>27</a:t>
             </a:r>
           </a:p>
         </p:txBody>
@@ -11025,19 +11153,198 @@
           <a:p>
             <a:pPr algn="l"/>
             <a:r>
-              <a:rPr sz="1300" b="1" i="0" dirty="0">
+              <a:rPr sz="1300" b="1" i="0">
                 <a:solidFill>
                   <a:srgbClr val="1BAF7A"/>
                 </a:solidFill>
               </a:rPr>
-              <a:t>10 · TRAINING DYNAMICS</a:t>
+              <a:t>13 · RESULTS VI</a:t>
+            </a:r>
+          </a:p>
+        </p:txBody>
+      </p:sp>
+      <p:sp>
+        <p:nvSpPr>
+          <p:cNvPr id="3" name="TextBox 2"/>
+          <p:cNvSpPr txBox="1"/>
+          <p:nvPr/>
+        </p:nvSpPr>
+        <p:spPr>
+          <a:xfrm>
+            <a:off x="685800" y="786384"/>
+            <a:ext cx="10820095" cy="868680"/>
+          </a:xfrm>
+          <a:prstGeom prst="rect">
+            <a:avLst/>
+          </a:prstGeom>
+          <a:noFill/>
+        </p:spPr>
+        <p:txBody>
+          <a:bodyPr wrap="square" lIns="0" tIns="0" rIns="0" bIns="0">
+            <a:spAutoFit/>
+          </a:bodyPr>
+          <a:lstStyle/>
+          <a:p>
+            <a:pPr algn="l">
+              <a:lnSpc>
+                <a:spcPct val="105000"/>
+              </a:lnSpc>
+            </a:pPr>
+            <a:r>
+              <a:rPr sz="2800" b="1" i="0" dirty="0">
+                <a:solidFill>
+                  <a:srgbClr val="1F385C"/>
+                </a:solidFill>
+              </a:rPr>
+              <a:t>Noise robustness (Theorem 1, empirical)</a:t>
+            </a:r>
+          </a:p>
+        </p:txBody>
+      </p:sp>
+      <p:sp>
+        <p:nvSpPr>
+          <p:cNvPr id="4" name="TextBox 3"/>
+          <p:cNvSpPr txBox="1"/>
+          <p:nvPr/>
+        </p:nvSpPr>
+        <p:spPr>
+          <a:xfrm>
+            <a:off x="685800" y="2054183"/>
+            <a:ext cx="3931920" cy="1882375"/>
+          </a:xfrm>
+          <a:prstGeom prst="rect">
+            <a:avLst/>
+          </a:prstGeom>
+          <a:noFill/>
+        </p:spPr>
+        <p:txBody>
+          <a:bodyPr wrap="square" lIns="0" tIns="0" rIns="0" bIns="0">
+            <a:spAutoFit/>
+          </a:bodyPr>
+          <a:lstStyle/>
+          <a:p>
+            <a:pPr algn="l">
+              <a:lnSpc>
+                <a:spcPct val="115000"/>
+              </a:lnSpc>
+              <a:spcAft>
+                <a:spcPts val="1600"/>
+              </a:spcAft>
+            </a:pPr>
+            <a:r>
+              <a:rPr sz="1400" b="0" i="0" dirty="0">
+                <a:solidFill>
+                  <a:srgbClr val="1BAF7A"/>
+                </a:solidFill>
+              </a:rPr>
+              <a:t>●   </a:t>
+            </a:r>
+            <a:r>
+              <a:rPr sz="1400" b="1" i="0" dirty="0" err="1">
+                <a:solidFill>
+                  <a:srgbClr val="1F385C"/>
+                </a:solidFill>
+              </a:rPr>
+              <a:t>GraphSAGE</a:t>
+            </a:r>
+            <a:r>
+              <a:rPr sz="1400" b="1" i="0" dirty="0">
+                <a:solidFill>
+                  <a:srgbClr val="1F385C"/>
+                </a:solidFill>
+              </a:rPr>
+              <a:t>-pool</a:t>
+            </a:r>
+            <a:r>
+              <a:rPr sz="1400" b="0" i="0" dirty="0">
+                <a:solidFill>
+                  <a:srgbClr val="262B33"/>
+                </a:solidFill>
+              </a:rPr>
+              <a:t> stays above both GCN and the raw-features baseline at every noise level</a:t>
+            </a:r>
+          </a:p>
+          <a:p>
+            <a:pPr algn="l">
+              <a:lnSpc>
+                <a:spcPct val="115000"/>
+              </a:lnSpc>
+              <a:spcAft>
+                <a:spcPts val="1600"/>
+              </a:spcAft>
+            </a:pPr>
+            <a:r>
+              <a:rPr sz="1400" b="0" i="0" dirty="0">
+                <a:solidFill>
+                  <a:srgbClr val="1BAF7A"/>
+                </a:solidFill>
+              </a:rPr>
+              <a:t>●   </a:t>
+            </a:r>
+            <a:r>
+              <a:rPr sz="1400" b="1" i="0" dirty="0">
+                <a:solidFill>
+                  <a:srgbClr val="1F385C"/>
+                </a:solidFill>
+              </a:rPr>
+              <a:t>GCN falls below raw features</a:t>
+            </a:r>
+            <a:r>
+              <a:rPr sz="1400" b="0" i="0" dirty="0">
+                <a:solidFill>
+                  <a:srgbClr val="262B33"/>
+                </a:solidFill>
+              </a:rPr>
+              <a:t> at full noise (0.389 vs. 0.393)</a:t>
+            </a:r>
+          </a:p>
+          <a:p>
+            <a:pPr algn="l">
+              <a:lnSpc>
+                <a:spcPct val="115000"/>
+              </a:lnSpc>
+              <a:spcAft>
+                <a:spcPts val="0"/>
+              </a:spcAft>
+            </a:pPr>
+            <a:r>
+              <a:rPr sz="1400" b="0" i="0" dirty="0">
+                <a:solidFill>
+                  <a:srgbClr val="1BAF7A"/>
+                </a:solidFill>
+              </a:rPr>
+              <a:t>●   </a:t>
+            </a:r>
+            <a:r>
+              <a:rPr sz="1400" b="0" i="0" dirty="0">
+                <a:solidFill>
+                  <a:srgbClr val="262B33"/>
+                </a:solidFill>
+              </a:rPr>
+              <a:t>Exactly the structural-reliance gap </a:t>
+            </a:r>
+            <a:r>
+              <a:rPr sz="1400" b="1" i="0" dirty="0">
+                <a:solidFill>
+                  <a:srgbClr val="1F385C"/>
+                </a:solidFill>
+              </a:rPr>
+              <a:t>Theorem 1</a:t>
+            </a:r>
+            <a:r>
+              <a:rPr sz="1400" b="0" i="0" dirty="0">
+                <a:solidFill>
+                  <a:srgbClr val="262B33"/>
+                </a:solidFill>
+              </a:rPr>
+              <a:t> predicts</a:t>
             </a:r>
           </a:p>
         </p:txBody>
       </p:sp>
       <p:pic>
         <p:nvPicPr>
-          <p:cNvPr id="3" name="Picture 3" descr="panel3.png"/>
+          <p:cNvPr id="5" name="Picture 4" descr="slide21_img22.png"/>
           <p:cNvPicPr>
             <a:picLocks noChangeAspect="1"/>
           </p:cNvPicPr>
@@ -11051,89 +11358,17 @@
         </p:blipFill>
         <p:spPr>
           <a:xfrm>
-            <a:off x="2642067" y="900000"/>
-            <a:ext cx="3253780" cy="2585000"/>
+            <a:off x="5141762" y="1783080"/>
+            <a:ext cx="6205849" cy="4297680"/>
           </a:xfrm>
           <a:prstGeom prst="rect">
             <a:avLst/>
           </a:prstGeom>
         </p:spPr>
       </p:pic>
-      <p:pic>
-        <p:nvPicPr>
-          <p:cNvPr id="4" name="Picture 4" descr="panel4.png"/>
-          <p:cNvPicPr>
-            <a:picLocks noChangeAspect="1"/>
-          </p:cNvPicPr>
-          <p:nvPr/>
-        </p:nvPicPr>
-        <p:blipFill>
-          <a:blip r:embed="rId3"/>
-          <a:stretch>
-            <a:fillRect/>
-          </a:stretch>
-        </p:blipFill>
-        <p:spPr>
-          <a:xfrm>
-            <a:off x="6295847" y="900000"/>
-            <a:ext cx="3253780" cy="2585000"/>
-          </a:xfrm>
-          <a:prstGeom prst="rect">
-            <a:avLst/>
-          </a:prstGeom>
-        </p:spPr>
-      </p:pic>
-      <p:pic>
-        <p:nvPicPr>
-          <p:cNvPr id="5" name="Picture 5" descr="panel5.png"/>
-          <p:cNvPicPr>
-            <a:picLocks noChangeAspect="1"/>
-          </p:cNvPicPr>
-          <p:nvPr/>
-        </p:nvPicPr>
-        <p:blipFill>
-          <a:blip r:embed="rId4"/>
-          <a:stretch>
-            <a:fillRect/>
-          </a:stretch>
-        </p:blipFill>
-        <p:spPr>
-          <a:xfrm>
-            <a:off x="2642067" y="3765000"/>
-            <a:ext cx="3253780" cy="2585000"/>
-          </a:xfrm>
-          <a:prstGeom prst="rect">
-            <a:avLst/>
-          </a:prstGeom>
-        </p:spPr>
-      </p:pic>
-      <p:pic>
-        <p:nvPicPr>
-          <p:cNvPr id="6" name="Picture 6" descr="panel6.png"/>
-          <p:cNvPicPr>
-            <a:picLocks noChangeAspect="1"/>
-          </p:cNvPicPr>
-          <p:nvPr/>
-        </p:nvPicPr>
-        <p:blipFill>
-          <a:blip r:embed="rId5"/>
-          <a:stretch>
-            <a:fillRect/>
-          </a:stretch>
-        </p:blipFill>
-        <p:spPr>
-          <a:xfrm>
-            <a:off x="6295847" y="3765000"/>
-            <a:ext cx="3253780" cy="2585000"/>
-          </a:xfrm>
-          <a:prstGeom prst="rect">
-            <a:avLst/>
-          </a:prstGeom>
-        </p:spPr>
-      </p:pic>
-      <p:sp>
-        <p:nvSpPr>
-          <p:cNvPr id="7" name="TextBox 6"/>
+      <p:sp>
+        <p:nvSpPr>
+          <p:cNvPr id="6" name="TextBox 5"/>
           <p:cNvSpPr txBox="1"/>
           <p:nvPr/>
         </p:nvSpPr>
@@ -11160,7 +11395,7 @@
                   <a:srgbClr val="9AA5B1"/>
                 </a:solidFill>
               </a:rPr>
-              <a:t>20</a:t>
+              <a:t>28</a:t>
             </a:r>
           </a:p>
         </p:txBody>
@@ -11214,122 +11449,26 @@
           <a:p>
             <a:pPr algn="l"/>
             <a:r>
-              <a:rPr sz="1300" b="1" i="0" dirty="0">
+              <a:rPr sz="1300" b="1" i="0">
                 <a:solidFill>
                   <a:srgbClr val="1BAF7A"/>
                 </a:solidFill>
               </a:rPr>
-              <a:t>10 · TRAINING DYNAMICS</a:t>
-            </a:r>
-          </a:p>
-        </p:txBody>
-      </p:sp>
-      <p:pic>
-        <p:nvPicPr>
-          <p:cNvPr id="3" name="Picture 3" descr="panel3.png"/>
-          <p:cNvPicPr>
-            <a:picLocks noChangeAspect="1"/>
-          </p:cNvPicPr>
-          <p:nvPr/>
-        </p:nvPicPr>
-        <p:blipFill>
-          <a:blip r:embed="rId2"/>
-          <a:stretch>
-            <a:fillRect/>
-          </a:stretch>
-        </p:blipFill>
-        <p:spPr>
-          <a:xfrm>
-            <a:off x="2642067" y="900000"/>
-            <a:ext cx="3253780" cy="2585000"/>
-          </a:xfrm>
-          <a:prstGeom prst="rect">
-            <a:avLst/>
-          </a:prstGeom>
-        </p:spPr>
-      </p:pic>
-      <p:pic>
-        <p:nvPicPr>
-          <p:cNvPr id="4" name="Picture 4" descr="panel4.png"/>
-          <p:cNvPicPr>
-            <a:picLocks noChangeAspect="1"/>
-          </p:cNvPicPr>
-          <p:nvPr/>
-        </p:nvPicPr>
-        <p:blipFill>
-          <a:blip r:embed="rId3"/>
-          <a:stretch>
-            <a:fillRect/>
-          </a:stretch>
-        </p:blipFill>
-        <p:spPr>
-          <a:xfrm>
-            <a:off x="6295847" y="900000"/>
-            <a:ext cx="3253780" cy="2585000"/>
-          </a:xfrm>
-          <a:prstGeom prst="rect">
-            <a:avLst/>
-          </a:prstGeom>
-        </p:spPr>
-      </p:pic>
-      <p:pic>
-        <p:nvPicPr>
-          <p:cNvPr id="5" name="Picture 5" descr="panel5.png"/>
-          <p:cNvPicPr>
-            <a:picLocks noChangeAspect="1"/>
-          </p:cNvPicPr>
-          <p:nvPr/>
-        </p:nvPicPr>
-        <p:blipFill>
-          <a:blip r:embed="rId4"/>
-          <a:stretch>
-            <a:fillRect/>
-          </a:stretch>
-        </p:blipFill>
-        <p:spPr>
-          <a:xfrm>
-            <a:off x="2642067" y="3765000"/>
-            <a:ext cx="3253780" cy="2585000"/>
-          </a:xfrm>
-          <a:prstGeom prst="rect">
-            <a:avLst/>
-          </a:prstGeom>
-        </p:spPr>
-      </p:pic>
-      <p:pic>
-        <p:nvPicPr>
-          <p:cNvPr id="6" name="Picture 6" descr="panel6.png"/>
-          <p:cNvPicPr>
-            <a:picLocks noChangeAspect="1"/>
-          </p:cNvPicPr>
-          <p:nvPr/>
-        </p:nvPicPr>
-        <p:blipFill>
-          <a:blip r:embed="rId5"/>
-          <a:stretch>
-            <a:fillRect/>
-          </a:stretch>
-        </p:blipFill>
-        <p:spPr>
-          <a:xfrm>
-            <a:off x="6295847" y="3765000"/>
-            <a:ext cx="3253780" cy="2585000"/>
-          </a:xfrm>
-          <a:prstGeom prst="rect">
-            <a:avLst/>
-          </a:prstGeom>
-        </p:spPr>
-      </p:pic>
-      <p:sp>
-        <p:nvSpPr>
-          <p:cNvPr id="7" name="TextBox 6"/>
+              <a:t>14 · DISCUSSION &amp; CONCLUSIONS</a:t>
+            </a:r>
+          </a:p>
+        </p:txBody>
+      </p:sp>
+      <p:sp>
+        <p:nvSpPr>
+          <p:cNvPr id="3" name="TextBox 2"/>
           <p:cNvSpPr txBox="1"/>
           <p:nvPr/>
         </p:nvSpPr>
         <p:spPr>
           <a:xfrm>
-            <a:off x="11292840" y="6492240"/>
-            <a:ext cx="411480" cy="274320"/>
+            <a:off x="685800" y="786384"/>
+            <a:ext cx="10820095" cy="868680"/>
           </a:xfrm>
           <a:prstGeom prst="rect">
             <a:avLst/>
@@ -11342,6 +11481,273 @@
           </a:bodyPr>
           <a:lstStyle/>
           <a:p>
+            <a:pPr algn="l">
+              <a:lnSpc>
+                <a:spcPct val="105000"/>
+              </a:lnSpc>
+            </a:pPr>
+            <a:r>
+              <a:rPr sz="3000" b="1" i="0" dirty="0">
+                <a:solidFill>
+                  <a:srgbClr val="1F385C"/>
+                </a:solidFill>
+              </a:rPr>
+              <a:t>What this reproduction shows</a:t>
+            </a:r>
+          </a:p>
+        </p:txBody>
+      </p:sp>
+      <p:sp>
+        <p:nvSpPr>
+          <p:cNvPr id="4" name="TextBox 3"/>
+          <p:cNvSpPr txBox="1"/>
+          <p:nvPr/>
+        </p:nvSpPr>
+        <p:spPr>
+          <a:xfrm>
+            <a:off x="685800" y="2057400"/>
+            <a:ext cx="10820095" cy="1963358"/>
+          </a:xfrm>
+          <a:prstGeom prst="rect">
+            <a:avLst/>
+          </a:prstGeom>
+          <a:noFill/>
+        </p:spPr>
+        <p:txBody>
+          <a:bodyPr wrap="square" lIns="0" tIns="0" rIns="0" bIns="0">
+            <a:spAutoFit/>
+          </a:bodyPr>
+          <a:lstStyle/>
+          <a:p>
+            <a:pPr algn="l">
+              <a:lnSpc>
+                <a:spcPct val="115000"/>
+              </a:lnSpc>
+              <a:spcAft>
+                <a:spcPts val="2200"/>
+              </a:spcAft>
+            </a:pPr>
+            <a:r>
+              <a:rPr sz="1600" b="0" i="0" dirty="0">
+                <a:solidFill>
+                  <a:srgbClr val="1BAF7A"/>
+                </a:solidFill>
+              </a:rPr>
+              <a:t>●   </a:t>
+            </a:r>
+            <a:r>
+              <a:rPr sz="1600" b="0" i="0" dirty="0">
+                <a:solidFill>
+                  <a:srgbClr val="262B33"/>
+                </a:solidFill>
+              </a:rPr>
+              <a:t>Qualitative ordering </a:t>
+            </a:r>
+            <a:r>
+              <a:rPr sz="1600" b="1" i="0" dirty="0">
+                <a:solidFill>
+                  <a:srgbClr val="1F385C"/>
+                </a:solidFill>
+              </a:rPr>
+              <a:t>survives the scale</a:t>
+            </a:r>
+            <a:r>
+              <a:rPr lang="it-IT" sz="1600" b="1" i="0" dirty="0">
+                <a:solidFill>
+                  <a:srgbClr val="1F385C"/>
+                </a:solidFill>
+              </a:rPr>
+              <a:t> </a:t>
+            </a:r>
+            <a:r>
+              <a:rPr sz="1600" b="1" i="0" dirty="0">
+                <a:solidFill>
+                  <a:srgbClr val="1F385C"/>
+                </a:solidFill>
+              </a:rPr>
+              <a:t>down</a:t>
+            </a:r>
+            <a:r>
+              <a:rPr sz="1600" b="0" i="0" dirty="0">
+                <a:solidFill>
+                  <a:srgbClr val="262B33"/>
+                </a:solidFill>
+              </a:rPr>
+              <a:t>: </a:t>
+            </a:r>
+            <a:r>
+              <a:rPr sz="1600" b="0" i="0" dirty="0" err="1">
+                <a:solidFill>
+                  <a:srgbClr val="262B33"/>
+                </a:solidFill>
+              </a:rPr>
+              <a:t>GraphSAGE</a:t>
+            </a:r>
+            <a:r>
+              <a:rPr sz="1600" b="0" i="0" dirty="0">
+                <a:solidFill>
+                  <a:srgbClr val="262B33"/>
+                </a:solidFill>
+              </a:rPr>
+              <a:t> ≫ Raw features &gt; Random, supervised ≥ unsupervised — GCN weakest and pool strongest whether supervised or unsupervised, matching the paper's own ranking</a:t>
+            </a:r>
+          </a:p>
+          <a:p>
+            <a:pPr algn="l">
+              <a:lnSpc>
+                <a:spcPct val="115000"/>
+              </a:lnSpc>
+              <a:spcAft>
+                <a:spcPts val="2200"/>
+              </a:spcAft>
+            </a:pPr>
+            <a:r>
+              <a:rPr sz="1600" b="0" i="0" dirty="0">
+                <a:solidFill>
+                  <a:srgbClr val="1BAF7A"/>
+                </a:solidFill>
+              </a:rPr>
+              <a:t>●   </a:t>
+            </a:r>
+            <a:r>
+              <a:rPr sz="1600" b="0" i="0" dirty="0">
+                <a:solidFill>
+                  <a:srgbClr val="262B33"/>
+                </a:solidFill>
+              </a:rPr>
+              <a:t>Numerical gaps vs. paper explained by: reduced hyperparameter grid, fewer seeds, TensorFlow version drift, different hardware (1× RTX 2060 SUPER vs. 4× Titan X Pascal)</a:t>
+            </a:r>
+          </a:p>
+          <a:p>
+            <a:pPr algn="l">
+              <a:lnSpc>
+                <a:spcPct val="115000"/>
+              </a:lnSpc>
+              <a:spcAft>
+                <a:spcPts val="0"/>
+              </a:spcAft>
+            </a:pPr>
+            <a:r>
+              <a:rPr sz="1600" b="0" i="0" dirty="0">
+                <a:solidFill>
+                  <a:srgbClr val="1BAF7A"/>
+                </a:solidFill>
+              </a:rPr>
+              <a:t>●   </a:t>
+            </a:r>
+            <a:r>
+              <a:rPr sz="1600" b="0" i="0" dirty="0">
+                <a:solidFill>
+                  <a:srgbClr val="262B33"/>
+                </a:solidFill>
+              </a:rPr>
+              <a:t>Both theoretical claims (</a:t>
+            </a:r>
+            <a:r>
+              <a:rPr sz="1600" b="1" i="0" dirty="0">
+                <a:solidFill>
+                  <a:srgbClr val="1F385C"/>
+                </a:solidFill>
+              </a:rPr>
+              <a:t>K</a:t>
+            </a:r>
+            <a:r>
+              <a:rPr lang="it-IT" sz="1600" b="1" i="0" dirty="0">
+                <a:solidFill>
+                  <a:srgbClr val="1F385C"/>
+                </a:solidFill>
+              </a:rPr>
+              <a:t> </a:t>
+            </a:r>
+            <a:r>
+              <a:rPr sz="1600" b="1" i="0" dirty="0">
+                <a:solidFill>
+                  <a:srgbClr val="1F385C"/>
+                </a:solidFill>
+              </a:rPr>
+              <a:t>sensitivity</a:t>
+            </a:r>
+            <a:r>
+              <a:rPr sz="1600" b="0" i="0" dirty="0">
+                <a:solidFill>
+                  <a:srgbClr val="262B33"/>
+                </a:solidFill>
+              </a:rPr>
+              <a:t> and </a:t>
+            </a:r>
+            <a:r>
+              <a:rPr sz="1600" b="1" i="0" dirty="0">
+                <a:solidFill>
+                  <a:srgbClr val="1F385C"/>
+                </a:solidFill>
+              </a:rPr>
+              <a:t>noise</a:t>
+            </a:r>
+            <a:r>
+              <a:rPr lang="it-IT" sz="1600" b="1" i="0" dirty="0">
+                <a:solidFill>
+                  <a:srgbClr val="1F385C"/>
+                </a:solidFill>
+              </a:rPr>
+              <a:t> </a:t>
+            </a:r>
+            <a:r>
+              <a:rPr sz="1600" b="1" i="0" dirty="0">
+                <a:solidFill>
+                  <a:srgbClr val="1F385C"/>
+                </a:solidFill>
+              </a:rPr>
+              <a:t>robustness</a:t>
+            </a:r>
+            <a:r>
+              <a:rPr sz="1600" b="0" i="0" dirty="0">
+                <a:solidFill>
+                  <a:srgbClr val="262B33"/>
+                </a:solidFill>
+              </a:rPr>
+              <a:t>) independently </a:t>
+            </a:r>
+            <a:r>
+              <a:rPr sz="1600" b="1" i="0" dirty="0">
+                <a:solidFill>
+                  <a:srgbClr val="1F385C"/>
+                </a:solidFill>
+              </a:rPr>
+              <a:t>verified on PPI</a:t>
+            </a:r>
+            <a:r>
+              <a:rPr sz="1600" b="0" i="0" dirty="0">
+                <a:solidFill>
+                  <a:srgbClr val="262B33"/>
+                </a:solidFill>
+              </a:rPr>
+              <a:t>, not just asserted from the paper</a:t>
+            </a:r>
+          </a:p>
+        </p:txBody>
+      </p:sp>
+      <p:sp>
+        <p:nvSpPr>
+          <p:cNvPr id="5" name="TextBox 4"/>
+          <p:cNvSpPr txBox="1"/>
+          <p:nvPr/>
+        </p:nvSpPr>
+        <p:spPr>
+          <a:xfrm>
+            <a:off x="11292840" y="6492240"/>
+            <a:ext cx="411480" cy="274320"/>
+          </a:xfrm>
+          <a:prstGeom prst="rect">
+            <a:avLst/>
+          </a:prstGeom>
+          <a:noFill/>
+        </p:spPr>
+        <p:txBody>
+          <a:bodyPr wrap="square" lIns="0" tIns="0" rIns="0" bIns="0">
+            <a:spAutoFit/>
+          </a:bodyPr>
+          <a:lstStyle/>
+          <a:p>
             <a:pPr algn="r"/>
             <a:r>
               <a:rPr sz="1100" b="0" i="0">
@@ -11349,7 +11755,7 @@
                   <a:srgbClr val="9AA5B1"/>
                 </a:solidFill>
               </a:rPr>
-              <a:t>21</a:t>
+              <a:t>29</a:t>
             </a:r>
           </a:p>
         </p:txBody>
@@ -11785,7 +12191,7 @@
         </p:blipFill>
         <p:spPr>
           <a:xfrm>
-            <a:off x="1601762" y="2546749"/>
+            <a:off x="1601762" y="2714732"/>
             <a:ext cx="8981846" cy="3686068"/>
           </a:xfrm>
           <a:prstGeom prst="rect">
@@ -11793,64 +12199,6 @@
           </a:prstGeom>
         </p:spPr>
       </p:pic>
-      <p:sp>
-        <p:nvSpPr>
-          <p:cNvPr id="6" name="TextBox 5"/>
-          <p:cNvSpPr txBox="1"/>
-          <p:nvPr/>
-        </p:nvSpPr>
-        <p:spPr>
-          <a:xfrm>
-            <a:off x="3940395" y="6363787"/>
-            <a:ext cx="4304584" cy="161583"/>
-          </a:xfrm>
-          <a:prstGeom prst="rect">
-            <a:avLst/>
-          </a:prstGeom>
-          <a:noFill/>
-        </p:spPr>
-        <p:txBody>
-          <a:bodyPr wrap="square" lIns="0" tIns="0" rIns="0" bIns="0">
-            <a:spAutoFit/>
-          </a:bodyPr>
-          <a:lstStyle/>
-          <a:p>
-            <a:pPr algn="ctr"/>
-            <a:r>
-              <a:rPr sz="1050" b="0" i="1" dirty="0">
-                <a:solidFill>
-                  <a:srgbClr val="55606B"/>
-                </a:solidFill>
-              </a:rPr>
-              <a:t>K = |V|, identity weights, and a hash-like (injective) aggregator ⇔ exactly the </a:t>
-            </a:r>
-            <a:r>
-              <a:rPr sz="1050" b="1" i="1" dirty="0" err="1">
-                <a:solidFill>
-                  <a:srgbClr val="55606B"/>
-                </a:solidFill>
-              </a:rPr>
-              <a:t>Weisfeiler</a:t>
-            </a:r>
-            <a:r>
-              <a:rPr sz="1050" b="1" i="1" dirty="0">
-                <a:solidFill>
-                  <a:srgbClr val="55606B"/>
-                </a:solidFill>
-              </a:rPr>
-              <a:t>-Lehman</a:t>
-            </a:r>
-            <a:r>
-              <a:rPr sz="1050" b="0" i="1" dirty="0">
-                <a:solidFill>
-                  <a:srgbClr val="55606B"/>
-                </a:solidFill>
-              </a:rPr>
-              <a:t> isomorphism test</a:t>
-            </a:r>
-          </a:p>
-        </p:txBody>
-      </p:sp>
       <p:sp>
         <p:nvSpPr>
           <p:cNvPr id="7" name="TextBox 6"/>
@@ -11912,14 +12260,59 @@
       </p:grpSpPr>
       <p:sp>
         <p:nvSpPr>
-          <p:cNvPr id="2" name="TextBox 1"/>
+          <p:cNvPr id="2" name="Rectangle 1"/>
+          <p:cNvSpPr/>
+          <p:nvPr/>
+        </p:nvSpPr>
+        <p:spPr>
+          <a:xfrm>
+            <a:off x="0" y="0"/>
+            <a:ext cx="82296" cy="6858000"/>
+          </a:xfrm>
+          <a:prstGeom prst="rect">
+            <a:avLst/>
+          </a:prstGeom>
+          <a:solidFill>
+            <a:srgbClr val="1BAF7A"/>
+          </a:solidFill>
+          <a:ln>
+            <a:noFill/>
+          </a:ln>
+          <a:effectLst/>
+        </p:spPr>
+        <p:style>
+          <a:lnRef idx="1">
+            <a:schemeClr val="accent1"/>
+          </a:lnRef>
+          <a:fillRef idx="3">
+            <a:schemeClr val="accent1"/>
+          </a:fillRef>
+          <a:effectRef idx="2">
+            <a:schemeClr val="accent1"/>
+          </a:effectRef>
+          <a:fontRef idx="minor">
+            <a:schemeClr val="lt1"/>
+          </a:fontRef>
+        </p:style>
+        <p:txBody>
+          <a:bodyPr rtlCol="0" anchor="ctr"/>
+          <a:lstStyle/>
+          <a:p>
+            <a:pPr algn="ctr"/>
+            <a:endParaRPr/>
+          </a:p>
+        </p:txBody>
+      </p:sp>
+      <p:sp>
+        <p:nvSpPr>
+          <p:cNvPr id="3" name="TextBox 2"/>
           <p:cNvSpPr txBox="1"/>
           <p:nvPr/>
         </p:nvSpPr>
         <p:spPr>
           <a:xfrm>
-            <a:off x="685800" y="457200"/>
-            <a:ext cx="10820095" cy="292608"/>
+            <a:off x="0" y="2880360"/>
+            <a:ext cx="12191695" cy="1097280"/>
           </a:xfrm>
           <a:prstGeom prst="rect">
             <a:avLst/>
@@ -11932,28 +12325,28 @@
           </a:bodyPr>
           <a:lstStyle/>
           <a:p>
-            <a:pPr algn="l"/>
-            <a:r>
-              <a:rPr sz="1300" b="1" i="0" dirty="0">
-                <a:solidFill>
-                  <a:srgbClr val="1BAF7A"/>
-                </a:solidFill>
-              </a:rPr>
-              <a:t>12 · RESULTS V</a:t>
-            </a:r>
-          </a:p>
-        </p:txBody>
-      </p:sp>
-      <p:sp>
-        <p:nvSpPr>
-          <p:cNvPr id="3" name="TextBox 2"/>
+            <a:pPr algn="ctr"/>
+            <a:r>
+              <a:rPr sz="4600" b="1" i="0">
+                <a:solidFill>
+                  <a:srgbClr val="1F385C"/>
+                </a:solidFill>
+              </a:rPr>
+              <a:t>Thank You</a:t>
+            </a:r>
+          </a:p>
+        </p:txBody>
+      </p:sp>
+      <p:sp>
+        <p:nvSpPr>
+          <p:cNvPr id="4" name="TextBox 3"/>
           <p:cNvSpPr txBox="1"/>
           <p:nvPr/>
         </p:nvSpPr>
         <p:spPr>
           <a:xfrm>
-            <a:off x="685800" y="786384"/>
-            <a:ext cx="10820095" cy="434093"/>
+            <a:off x="685800" y="6492240"/>
+            <a:ext cx="8686800" cy="274320"/>
           </a:xfrm>
           <a:prstGeom prst="rect">
             <a:avLst/>
@@ -11966,32 +12359,28 @@
           </a:bodyPr>
           <a:lstStyle/>
           <a:p>
-            <a:pPr algn="l">
-              <a:lnSpc>
-                <a:spcPct val="105000"/>
-              </a:lnSpc>
-            </a:pPr>
-            <a:r>
-              <a:rPr sz="2800" b="1" i="0" dirty="0">
-                <a:solidFill>
-                  <a:srgbClr val="1F385C"/>
-                </a:solidFill>
-              </a:rPr>
-              <a:t>Sample-size sensitivity</a:t>
-            </a:r>
-          </a:p>
-        </p:txBody>
-      </p:sp>
-      <p:sp>
-        <p:nvSpPr>
-          <p:cNvPr id="4" name="TextBox 3"/>
+            <a:pPr algn="l"/>
+            <a:r>
+              <a:rPr sz="1000" b="0" i="1">
+                <a:solidFill>
+                  <a:srgbClr val="9AA5B1"/>
+                </a:solidFill>
+              </a:rPr>
+              <a:t>GraphSAGE on PPI – Scaled Reproduction</a:t>
+            </a:r>
+          </a:p>
+        </p:txBody>
+      </p:sp>
+      <p:sp>
+        <p:nvSpPr>
+          <p:cNvPr id="5" name="TextBox 4"/>
           <p:cNvSpPr txBox="1"/>
           <p:nvPr/>
         </p:nvSpPr>
         <p:spPr>
           <a:xfrm>
-            <a:off x="685800" y="2297305"/>
-            <a:ext cx="3931920" cy="1634615"/>
+            <a:off x="11292840" y="6492240"/>
+            <a:ext cx="411480" cy="274320"/>
           </a:xfrm>
           <a:prstGeom prst="rect">
             <a:avLst/>
@@ -12004,171 +12393,14 @@
           </a:bodyPr>
           <a:lstStyle/>
           <a:p>
-            <a:pPr algn="l">
-              <a:lnSpc>
-                <a:spcPct val="115000"/>
-              </a:lnSpc>
-              <a:spcAft>
-                <a:spcPts val="1600"/>
-              </a:spcAft>
-            </a:pPr>
-            <a:r>
-              <a:rPr sz="1400" b="0" i="0" dirty="0">
-                <a:solidFill>
-                  <a:srgbClr val="1BAF7A"/>
-                </a:solidFill>
-              </a:rPr>
-              <a:t>●   </a:t>
-            </a:r>
-            <a:r>
-              <a:rPr sz="1400" b="1" i="0" dirty="0">
-                <a:solidFill>
-                  <a:srgbClr val="1F385C"/>
-                </a:solidFill>
-              </a:rPr>
-              <a:t>More neighbors help</a:t>
-            </a:r>
-            <a:r>
-              <a:rPr sz="1400" b="0" i="0" dirty="0">
-                <a:solidFill>
-                  <a:srgbClr val="262B33"/>
-                </a:solidFill>
-              </a:rPr>
-              <a:t>: 0.536 → 0.640 F1 from S=5 to S=75</a:t>
-            </a:r>
-          </a:p>
-          <a:p>
-            <a:pPr algn="l">
-              <a:lnSpc>
-                <a:spcPct val="115000"/>
-              </a:lnSpc>
-              <a:spcAft>
-                <a:spcPts val="1600"/>
-              </a:spcAft>
-            </a:pPr>
-            <a:r>
-              <a:rPr sz="1400" b="0" i="0" dirty="0">
-                <a:solidFill>
-                  <a:srgbClr val="1BAF7A"/>
-                </a:solidFill>
-              </a:rPr>
-              <a:t>●   </a:t>
-            </a:r>
-            <a:r>
-              <a:rPr sz="1400" b="1" i="0" dirty="0">
-                <a:solidFill>
-                  <a:srgbClr val="1F385C"/>
-                </a:solidFill>
-              </a:rPr>
-              <a:t>Diminishing returns</a:t>
-            </a:r>
-            <a:r>
-              <a:rPr sz="1400" b="0" i="0" dirty="0">
-                <a:solidFill>
-                  <a:srgbClr val="262B33"/>
-                </a:solidFill>
-              </a:rPr>
-              <a:t>: most of the gain lands by S=25 (0.593); doubling S again to 75 adds only ~0.05 more</a:t>
-            </a:r>
-          </a:p>
-          <a:p>
-            <a:pPr algn="l">
-              <a:lnSpc>
-                <a:spcPct val="115000"/>
-              </a:lnSpc>
-              <a:spcAft>
-                <a:spcPts val="0"/>
-              </a:spcAft>
-            </a:pPr>
-            <a:r>
-              <a:rPr sz="1400" b="0" i="0" dirty="0">
-                <a:solidFill>
-                  <a:srgbClr val="1BAF7A"/>
-                </a:solidFill>
-              </a:rPr>
-              <a:t>●   </a:t>
-            </a:r>
-            <a:r>
-              <a:rPr sz="1400" b="0" i="0" dirty="0">
-                <a:solidFill>
-                  <a:srgbClr val="262B33"/>
-                </a:solidFill>
-              </a:rPr>
-              <a:t>Same panel also shows the </a:t>
-            </a:r>
-            <a:r>
-              <a:rPr sz="1400" b="1" i="0" dirty="0">
-                <a:solidFill>
-                  <a:srgbClr val="1F385C"/>
-                </a:solidFill>
-              </a:rPr>
-              <a:t>runtime cost</a:t>
-            </a:r>
-            <a:r>
-              <a:rPr sz="1400" b="0" i="0" dirty="0">
-                <a:solidFill>
-                  <a:srgbClr val="262B33"/>
-                </a:solidFill>
-              </a:rPr>
-              <a:t> growing with S (0.35 → 0.83 sec/iteration)</a:t>
-            </a:r>
-          </a:p>
-        </p:txBody>
-      </p:sp>
-      <p:pic>
-        <p:nvPicPr>
-          <p:cNvPr id="5" name="Picture 4" descr="ppi_sample_size_sensitivity.png"/>
-          <p:cNvPicPr>
-            <a:picLocks noChangeAspect="1"/>
-          </p:cNvPicPr>
-          <p:nvPr/>
-        </p:nvPicPr>
-        <p:blipFill>
-          <a:blip r:embed="rId2"/>
-          <a:stretch>
-            <a:fillRect/>
-          </a:stretch>
-        </p:blipFill>
-        <p:spPr>
-          <a:xfrm>
-            <a:off x="5290032" y="1783080"/>
-            <a:ext cx="5909310" cy="4297680"/>
-          </a:xfrm>
-          <a:prstGeom prst="rect">
-            <a:avLst/>
-          </a:prstGeom>
-        </p:spPr>
-      </p:pic>
-      <p:sp>
-        <p:nvSpPr>
-          <p:cNvPr id="6" name="TextBox 5"/>
-          <p:cNvSpPr txBox="1"/>
-          <p:nvPr/>
-        </p:nvSpPr>
-        <p:spPr>
-          <a:xfrm>
-            <a:off x="11292840" y="6492240"/>
-            <a:ext cx="411480" cy="274320"/>
-          </a:xfrm>
-          <a:prstGeom prst="rect">
-            <a:avLst/>
-          </a:prstGeom>
-          <a:noFill/>
-        </p:spPr>
-        <p:txBody>
-          <a:bodyPr wrap="square" lIns="0" tIns="0" rIns="0" bIns="0">
-            <a:spAutoFit/>
-          </a:bodyPr>
-          <a:lstStyle/>
-          <a:p>
             <a:pPr algn="r"/>
             <a:r>
-              <a:rPr sz="1100" b="0" i="0" dirty="0">
+              <a:rPr sz="1100" b="0" i="0">
                 <a:solidFill>
                   <a:srgbClr val="9AA5B1"/>
                 </a:solidFill>
               </a:rPr>
-              <a:t>27</a:t>
+              <a:t>30</a:t>
             </a:r>
           </a:p>
         </p:txBody>
@@ -14026,7 +14258,7 @@
                   <a:srgbClr val="262B33"/>
                 </a:solidFill>
               </a:rPr>
-              <a:t>size=512, hidden dim 128 (×2 when concatenated), 20 negative samples (unsupervised) — code follows lines 8–16 every step, but line 14’s normalize runs once on the final embedding, not every hop</a:t>
+              <a:t>size=512, hidden dim 128 (×2 when concatenated), 20 negative samples (unsupervised)</a:t>
             </a:r>
           </a:p>
         </p:txBody>
@@ -14628,7 +14860,7 @@
         </p:nvSpPr>
         <p:spPr>
           <a:xfrm>
-            <a:off x="685800" y="5989320"/>
+            <a:off x="685801" y="6126480"/>
             <a:ext cx="10820095" cy="274320"/>
           </a:xfrm>
           <a:prstGeom prst="rect">

</xml_diff>

<commit_message>
Aggiorna la presentazione GraphSAGE con nuove informazioni e miglioramenti
</commit_message>
<xml_diff>
--- a/presentation/GraphSAGE_presentation.pptx
+++ b/presentation/GraphSAGE_presentation.pptx
@@ -331,7 +331,7 @@
           <a:p>
             <a:fld id="{5BCAD085-E8A6-8845-BD4E-CB4CCA059FC4}" type="datetimeFigureOut">
               <a:rPr lang="en-US" smtClean="0"/>
-              <a:t>9/16/2026</a:t>
+              <a:t>9/17/2026</a:t>
             </a:fld>
             <a:endParaRPr lang="en-US"/>
           </a:p>
@@ -499,7 +499,7 @@
           <a:p>
             <a:fld id="{5BCAD085-E8A6-8845-BD4E-CB4CCA059FC4}" type="datetimeFigureOut">
               <a:rPr lang="en-US" smtClean="0"/>
-              <a:t>9/16/2026</a:t>
+              <a:t>9/17/2026</a:t>
             </a:fld>
             <a:endParaRPr lang="en-US"/>
           </a:p>
@@ -677,7 +677,7 @@
           <a:p>
             <a:fld id="{5BCAD085-E8A6-8845-BD4E-CB4CCA059FC4}" type="datetimeFigureOut">
               <a:rPr lang="en-US" smtClean="0"/>
-              <a:t>9/16/2026</a:t>
+              <a:t>9/17/2026</a:t>
             </a:fld>
             <a:endParaRPr lang="en-US"/>
           </a:p>
@@ -845,7 +845,7 @@
           <a:p>
             <a:fld id="{5BCAD085-E8A6-8845-BD4E-CB4CCA059FC4}" type="datetimeFigureOut">
               <a:rPr lang="en-US" smtClean="0"/>
-              <a:t>9/16/2026</a:t>
+              <a:t>9/17/2026</a:t>
             </a:fld>
             <a:endParaRPr lang="en-US"/>
           </a:p>
@@ -1090,7 +1090,7 @@
           <a:p>
             <a:fld id="{5BCAD085-E8A6-8845-BD4E-CB4CCA059FC4}" type="datetimeFigureOut">
               <a:rPr lang="en-US" smtClean="0"/>
-              <a:t>9/16/2026</a:t>
+              <a:t>9/17/2026</a:t>
             </a:fld>
             <a:endParaRPr lang="en-US"/>
           </a:p>
@@ -1375,7 +1375,7 @@
           <a:p>
             <a:fld id="{5BCAD085-E8A6-8845-BD4E-CB4CCA059FC4}" type="datetimeFigureOut">
               <a:rPr lang="en-US" smtClean="0"/>
-              <a:t>9/16/2026</a:t>
+              <a:t>9/17/2026</a:t>
             </a:fld>
             <a:endParaRPr lang="en-US"/>
           </a:p>
@@ -1794,7 +1794,7 @@
           <a:p>
             <a:fld id="{5BCAD085-E8A6-8845-BD4E-CB4CCA059FC4}" type="datetimeFigureOut">
               <a:rPr lang="en-US" smtClean="0"/>
-              <a:t>9/16/2026</a:t>
+              <a:t>9/17/2026</a:t>
             </a:fld>
             <a:endParaRPr lang="en-US"/>
           </a:p>
@@ -1911,7 +1911,7 @@
           <a:p>
             <a:fld id="{5BCAD085-E8A6-8845-BD4E-CB4CCA059FC4}" type="datetimeFigureOut">
               <a:rPr lang="en-US" smtClean="0"/>
-              <a:t>9/16/2026</a:t>
+              <a:t>9/17/2026</a:t>
             </a:fld>
             <a:endParaRPr lang="en-US"/>
           </a:p>
@@ -2006,7 +2006,7 @@
           <a:p>
             <a:fld id="{5BCAD085-E8A6-8845-BD4E-CB4CCA059FC4}" type="datetimeFigureOut">
               <a:rPr lang="en-US" smtClean="0"/>
-              <a:t>9/16/2026</a:t>
+              <a:t>9/17/2026</a:t>
             </a:fld>
             <a:endParaRPr lang="en-US"/>
           </a:p>
@@ -2281,7 +2281,7 @@
           <a:p>
             <a:fld id="{5BCAD085-E8A6-8845-BD4E-CB4CCA059FC4}" type="datetimeFigureOut">
               <a:rPr lang="en-US" smtClean="0"/>
-              <a:t>9/16/2026</a:t>
+              <a:t>9/17/2026</a:t>
             </a:fld>
             <a:endParaRPr lang="en-US"/>
           </a:p>
@@ -2533,7 +2533,7 @@
           <a:p>
             <a:fld id="{5BCAD085-E8A6-8845-BD4E-CB4CCA059FC4}" type="datetimeFigureOut">
               <a:rPr lang="en-US" smtClean="0"/>
-              <a:t>9/16/2026</a:t>
+              <a:t>9/17/2026</a:t>
             </a:fld>
             <a:endParaRPr lang="en-US"/>
           </a:p>
@@ -2744,7 +2744,7 @@
           <a:p>
             <a:fld id="{5BCAD085-E8A6-8845-BD4E-CB4CCA059FC4}" type="datetimeFigureOut">
               <a:rPr lang="en-US" smtClean="0"/>
-              <a:t>9/16/2026</a:t>
+              <a:t>9/17/2026</a:t>
             </a:fld>
             <a:endParaRPr lang="en-US"/>
           </a:p>
@@ -11619,13 +11619,10 @@
             </a:r>
           </a:p>
           <a:p>
-            <a:pPr algn="l">
+            <a:pPr>
               <a:lnSpc>
                 <a:spcPct val="115000"/>
               </a:lnSpc>
-              <a:spcAft>
-                <a:spcPts val="0"/>
-              </a:spcAft>
             </a:pPr>
             <a:r>
               <a:rPr sz="1600" b="0" i="0" dirty="0">
@@ -11636,12 +11633,28 @@
               <a:t>●   </a:t>
             </a:r>
             <a:r>
+              <a:rPr lang="it-IT" sz="1600" dirty="0">
+                <a:solidFill>
+                  <a:srgbClr val="262B33"/>
+                </a:solidFill>
+              </a:rPr>
+              <a:t>T</a:t>
+            </a:r>
+            <a:r>
+              <a:rPr sz="1600" b="0" i="0" dirty="0" err="1">
+                <a:solidFill>
+                  <a:srgbClr val="262B33"/>
+                </a:solidFill>
+              </a:rPr>
+              <a:t>heoretical</a:t>
+            </a:r>
+            <a:r>
               <a:rPr sz="1600" b="0" i="0" dirty="0">
                 <a:solidFill>
                   <a:srgbClr val="262B33"/>
                 </a:solidFill>
               </a:rPr>
-              <a:t>Both theoretical claims (</a:t>
+              <a:t> claims (</a:t>
             </a:r>
             <a:r>
               <a:rPr sz="1600" b="1" i="0" dirty="0">
@@ -11657,15 +11670,55 @@
                   <a:srgbClr val="1F385C"/>
                 </a:solidFill>
               </a:rPr>
+              <a:t>, </a:t>
+            </a:r>
+            <a:r>
+              <a:rPr lang="it-IT" sz="1600" b="1" dirty="0">
+                <a:solidFill>
+                  <a:srgbClr val="1F385C"/>
+                </a:solidFill>
+              </a:rPr>
+              <a:t>sample-size sensitivity</a:t>
+            </a:r>
+            <a:r>
+              <a:rPr lang="it-IT" sz="1600" dirty="0">
+                <a:solidFill>
+                  <a:srgbClr val="262B33"/>
+                </a:solidFill>
+              </a:rPr>
               <a:t> </a:t>
             </a:r>
             <a:r>
+              <a:rPr sz="1600" b="0" i="0" dirty="0">
+                <a:solidFill>
+                  <a:srgbClr val="262B33"/>
+                </a:solidFill>
+              </a:rPr>
+              <a:t>and </a:t>
+            </a:r>
+            <a:r>
               <a:rPr sz="1600" b="1" i="0" dirty="0">
                 <a:solidFill>
                   <a:srgbClr val="1F385C"/>
                 </a:solidFill>
               </a:rPr>
-              <a:t>sensitivity</a:t>
+              <a:t>noise</a:t>
+            </a:r>
+            <a:r>
+              <a:rPr lang="it-IT" sz="1600" b="1" i="0" dirty="0">
+                <a:solidFill>
+                  <a:srgbClr val="1F385C"/>
+                </a:solidFill>
+              </a:rPr>
+              <a:t> </a:t>
+            </a:r>
+            <a:r>
+              <a:rPr sz="1600" b="1" i="0" dirty="0">
+                <a:solidFill>
+                  <a:srgbClr val="1F385C"/>
+                </a:solidFill>
+              </a:rPr>
+              <a:t>robustness</a:t>
             </a:r>
             <a:r>
               <a:rPr sz="1600" b="0" i="0" dirty="0">
@@ -11673,7 +11726,7 @@
                   <a:srgbClr val="262B33"/>
                 </a:solidFill>
               </a:rPr>
-              <a:t> and </a:t>
+              <a:t>) independently </a:t>
             </a:r>
             <a:r>
               <a:rPr sz="1600" b="1" i="0" dirty="0">
@@ -11681,23 +11734,7 @@
                   <a:srgbClr val="1F385C"/>
                 </a:solidFill>
               </a:rPr>
-              <a:t>noise</a:t>
-            </a:r>
-            <a:r>
-              <a:rPr lang="it-IT" sz="1600" b="1" i="0" dirty="0">
-                <a:solidFill>
-                  <a:srgbClr val="1F385C"/>
-                </a:solidFill>
-              </a:rPr>
-              <a:t> </a:t>
-            </a:r>
-            <a:r>
-              <a:rPr sz="1600" b="1" i="0" dirty="0">
-                <a:solidFill>
-                  <a:srgbClr val="1F385C"/>
-                </a:solidFill>
-              </a:rPr>
-              <a:t>robustness</a:t>
+              <a:t>verified on PPI</a:t>
             </a:r>
             <a:r>
               <a:rPr sz="1600" b="0" i="0" dirty="0">
@@ -11705,24 +11742,21 @@
                   <a:srgbClr val="262B33"/>
                 </a:solidFill>
               </a:rPr>
-              <a:t>) independently </a:t>
-            </a:r>
-            <a:r>
-              <a:rPr sz="1600" b="1" i="0" dirty="0">
-                <a:solidFill>
-                  <a:srgbClr val="1F385C"/>
-                </a:solidFill>
-              </a:rPr>
-              <a:t>verified on PPI</a:t>
-            </a:r>
-            <a:r>
-              <a:rPr sz="1600" b="0" i="0" dirty="0">
-                <a:solidFill>
-                  <a:srgbClr val="262B33"/>
-                </a:solidFill>
-              </a:rPr>
-              <a:t>, not just asserted from the paper</a:t>
-            </a:r>
+              <a:t>, not just asserted</a:t>
+            </a:r>
+            <a:r>
+              <a:rPr lang="it-IT" sz="1600" b="0" i="0" dirty="0">
+                <a:solidFill>
+                  <a:srgbClr val="262B33"/>
+                </a:solidFill>
+              </a:rPr>
+              <a:t>.</a:t>
+            </a:r>
+            <a:endParaRPr sz="1600" b="0" i="0" dirty="0">
+              <a:solidFill>
+                <a:srgbClr val="262B33"/>
+              </a:solidFill>
+            </a:endParaRPr>
           </a:p>
         </p:txBody>
       </p:sp>

</xml_diff>